<commit_message>
Add Foundry Blog Highlights section to Feb 2026 edition
</commit_message>
<xml_diff>
--- a/whats-new-microsoft-ai-feb2026.pptx
+++ b/whats-new-microsoft-ai-feb2026.pptx
@@ -16,6 +16,7 @@
     <p:sldId id="264" r:id="rId15"/>
     <p:sldId id="265" r:id="rId16"/>
     <p:sldId id="266" r:id="rId17"/>
+    <p:sldId id="267" r:id="rId18"/>
   </p:sldIdLst>
   <p:sldSz cx="12191695" cy="6858000" type="screen4x3"/>
   <p:notesSz cx="6858000" cy="9144000"/>
@@ -3393,7 +3394,7 @@
               </a:defRPr>
             </a:pPr>
             <a:r>
-              <a:t>Key Links &amp; Resources</a:t>
+              <a:t>Key February 2026 Updates – Quick Reference</a:t>
             </a:r>
           </a:p>
         </p:txBody>
@@ -3441,654 +3442,1162 @@
           </a:p>
         </p:txBody>
       </p:sp>
-      <p:sp>
-        <p:nvSpPr>
-          <p:cNvPr id="5" name="TextBox 4"/>
-          <p:cNvSpPr txBox="1"/>
+      <p:graphicFrame>
+        <p:nvGraphicFramePr>
+          <p:cNvPr id="5" name="Table 4"/>
+          <p:cNvGraphicFramePr>
+            <a:graphicFrameLocks noGrp="1"/>
+          </p:cNvGraphicFramePr>
           <p:nvPr/>
-        </p:nvSpPr>
-        <p:spPr>
-          <a:xfrm>
-            <a:off x="914400" y="1463040"/>
-            <a:ext cx="3657600" cy="365760"/>
-          </a:xfrm>
-          <a:prstGeom prst="rect">
-            <a:avLst/>
-          </a:prstGeom>
-          <a:noFill/>
-        </p:spPr>
-        <p:txBody>
-          <a:bodyPr wrap="square">
-            <a:spAutoFit/>
-          </a:bodyPr>
-          <a:lstStyle/>
-          <a:p>
-            <a:pPr algn="l">
-              <a:defRPr sz="1600" b="1">
-                <a:solidFill>
-                  <a:srgbClr val="0078D4"/>
-                </a:solidFill>
-                <a:latin typeface="Segoe UI"/>
-              </a:defRPr>
-            </a:pPr>
-            <a:r>
-              <a:t>Microsoft Foundry Portal</a:t>
-            </a:r>
-          </a:p>
-        </p:txBody>
-      </p:sp>
-      <p:sp>
-        <p:nvSpPr>
-          <p:cNvPr id="6" name="TextBox 5"/>
-          <p:cNvSpPr txBox="1"/>
-          <p:nvPr/>
-        </p:nvSpPr>
-        <p:spPr>
-          <a:xfrm>
-            <a:off x="4754880" y="1463040"/>
-            <a:ext cx="6858000" cy="365760"/>
-          </a:xfrm>
-          <a:prstGeom prst="rect">
-            <a:avLst/>
-          </a:prstGeom>
-          <a:noFill/>
-        </p:spPr>
-        <p:txBody>
-          <a:bodyPr wrap="square">
-            <a:spAutoFit/>
-          </a:bodyPr>
-          <a:lstStyle/>
-          <a:p>
-            <a:pPr algn="l">
-              <a:defRPr sz="1400" b="0">
-                <a:solidFill>
-                  <a:srgbClr val="CCCCCC"/>
-                </a:solidFill>
-                <a:latin typeface="Segoe UI"/>
-              </a:defRPr>
-            </a:pPr>
-            <a:r>
-              <a:t>https://ai.azure.com/</a:t>
-            </a:r>
-          </a:p>
-        </p:txBody>
-      </p:sp>
-      <p:sp>
-        <p:nvSpPr>
-          <p:cNvPr id="7" name="TextBox 6"/>
-          <p:cNvSpPr txBox="1"/>
-          <p:nvPr/>
-        </p:nvSpPr>
-        <p:spPr>
-          <a:xfrm>
-            <a:off x="914400" y="1965960"/>
-            <a:ext cx="3657600" cy="365760"/>
-          </a:xfrm>
-          <a:prstGeom prst="rect">
-            <a:avLst/>
-          </a:prstGeom>
-          <a:noFill/>
-        </p:spPr>
-        <p:txBody>
-          <a:bodyPr wrap="square">
-            <a:spAutoFit/>
-          </a:bodyPr>
-          <a:lstStyle/>
-          <a:p>
-            <a:pPr algn="l">
-              <a:defRPr sz="1600" b="1">
-                <a:solidFill>
-                  <a:srgbClr val="0078D4"/>
-                </a:solidFill>
-                <a:latin typeface="Segoe UI"/>
-              </a:defRPr>
-            </a:pPr>
-            <a:r>
-              <a:t>Foundry Product Page</a:t>
-            </a:r>
-          </a:p>
-        </p:txBody>
-      </p:sp>
-      <p:sp>
-        <p:nvSpPr>
-          <p:cNvPr id="8" name="TextBox 7"/>
-          <p:cNvSpPr txBox="1"/>
-          <p:nvPr/>
-        </p:nvSpPr>
-        <p:spPr>
-          <a:xfrm>
-            <a:off x="4754880" y="1965960"/>
-            <a:ext cx="6858000" cy="365760"/>
-          </a:xfrm>
-          <a:prstGeom prst="rect">
-            <a:avLst/>
-          </a:prstGeom>
-          <a:noFill/>
-        </p:spPr>
-        <p:txBody>
-          <a:bodyPr wrap="square">
-            <a:spAutoFit/>
-          </a:bodyPr>
-          <a:lstStyle/>
-          <a:p>
-            <a:pPr algn="l">
-              <a:defRPr sz="1400" b="0">
-                <a:solidFill>
-                  <a:srgbClr val="CCCCCC"/>
-                </a:solidFill>
-                <a:latin typeface="Segoe UI"/>
-              </a:defRPr>
-            </a:pPr>
-            <a:r>
-              <a:t>https://azure.microsoft.com/en-us/products/ai-foundry/</a:t>
-            </a:r>
-          </a:p>
-        </p:txBody>
-      </p:sp>
-      <p:sp>
-        <p:nvSpPr>
-          <p:cNvPr id="9" name="TextBox 8"/>
-          <p:cNvSpPr txBox="1"/>
-          <p:nvPr/>
-        </p:nvSpPr>
-        <p:spPr>
-          <a:xfrm>
-            <a:off x="914400" y="2468880"/>
-            <a:ext cx="3657600" cy="365760"/>
-          </a:xfrm>
-          <a:prstGeom prst="rect">
-            <a:avLst/>
-          </a:prstGeom>
-          <a:noFill/>
-        </p:spPr>
-        <p:txBody>
-          <a:bodyPr wrap="square">
-            <a:spAutoFit/>
-          </a:bodyPr>
-          <a:lstStyle/>
-          <a:p>
-            <a:pPr algn="l">
-              <a:defRPr sz="1600" b="1">
-                <a:solidFill>
-                  <a:srgbClr val="0078D4"/>
-                </a:solidFill>
-                <a:latin typeface="Segoe UI"/>
-              </a:defRPr>
-            </a:pPr>
-            <a:r>
-              <a:t>Azure OpenAI What’s New</a:t>
-            </a:r>
-          </a:p>
-        </p:txBody>
-      </p:sp>
-      <p:sp>
-        <p:nvSpPr>
-          <p:cNvPr id="10" name="TextBox 9"/>
-          <p:cNvSpPr txBox="1"/>
-          <p:nvPr/>
-        </p:nvSpPr>
-        <p:spPr>
-          <a:xfrm>
-            <a:off x="4754880" y="2468880"/>
-            <a:ext cx="6858000" cy="365760"/>
-          </a:xfrm>
-          <a:prstGeom prst="rect">
-            <a:avLst/>
-          </a:prstGeom>
-          <a:noFill/>
-        </p:spPr>
-        <p:txBody>
-          <a:bodyPr wrap="square">
-            <a:spAutoFit/>
-          </a:bodyPr>
-          <a:lstStyle/>
-          <a:p>
-            <a:pPr algn="l">
-              <a:defRPr sz="1400" b="0">
-                <a:solidFill>
-                  <a:srgbClr val="CCCCCC"/>
-                </a:solidFill>
-                <a:latin typeface="Segoe UI"/>
-              </a:defRPr>
-            </a:pPr>
-            <a:r>
-              <a:t>https://learn.microsoft.com/en-us/azure/ai-foundry/openai/whats-new</a:t>
-            </a:r>
-          </a:p>
-        </p:txBody>
-      </p:sp>
-      <p:sp>
-        <p:nvSpPr>
-          <p:cNvPr id="11" name="TextBox 10"/>
-          <p:cNvSpPr txBox="1"/>
-          <p:nvPr/>
-        </p:nvSpPr>
-        <p:spPr>
-          <a:xfrm>
-            <a:off x="914400" y="2971800"/>
-            <a:ext cx="3657600" cy="365760"/>
-          </a:xfrm>
-          <a:prstGeom prst="rect">
-            <a:avLst/>
-          </a:prstGeom>
-          <a:noFill/>
-        </p:spPr>
-        <p:txBody>
-          <a:bodyPr wrap="square">
-            <a:spAutoFit/>
-          </a:bodyPr>
-          <a:lstStyle/>
-          <a:p>
-            <a:pPr algn="l">
-              <a:defRPr sz="1600" b="1">
-                <a:solidFill>
-                  <a:srgbClr val="0078D4"/>
-                </a:solidFill>
-                <a:latin typeface="Segoe UI"/>
-              </a:defRPr>
-            </a:pPr>
-            <a:r>
-              <a:t>Model Retirements</a:t>
-            </a:r>
-          </a:p>
-        </p:txBody>
-      </p:sp>
-      <p:sp>
-        <p:nvSpPr>
-          <p:cNvPr id="12" name="TextBox 11"/>
-          <p:cNvSpPr txBox="1"/>
-          <p:nvPr/>
-        </p:nvSpPr>
-        <p:spPr>
-          <a:xfrm>
-            <a:off x="4754880" y="2971800"/>
-            <a:ext cx="6858000" cy="365760"/>
-          </a:xfrm>
-          <a:prstGeom prst="rect">
-            <a:avLst/>
-          </a:prstGeom>
-          <a:noFill/>
-        </p:spPr>
-        <p:txBody>
-          <a:bodyPr wrap="square">
-            <a:spAutoFit/>
-          </a:bodyPr>
-          <a:lstStyle/>
-          <a:p>
-            <a:pPr algn="l">
-              <a:defRPr sz="1400" b="0">
-                <a:solidFill>
-                  <a:srgbClr val="CCCCCC"/>
-                </a:solidFill>
-                <a:latin typeface="Segoe UI"/>
-              </a:defRPr>
-            </a:pPr>
-            <a:r>
-              <a:t>https://learn.microsoft.com/en-us/azure/ai-foundry/openai/concepts/model-retirements</a:t>
-            </a:r>
-          </a:p>
-        </p:txBody>
-      </p:sp>
-      <p:sp>
-        <p:nvSpPr>
-          <p:cNvPr id="13" name="TextBox 12"/>
-          <p:cNvSpPr txBox="1"/>
-          <p:nvPr/>
-        </p:nvSpPr>
-        <p:spPr>
-          <a:xfrm>
-            <a:off x="914400" y="3474720"/>
-            <a:ext cx="3657600" cy="365760"/>
-          </a:xfrm>
-          <a:prstGeom prst="rect">
-            <a:avLst/>
-          </a:prstGeom>
-          <a:noFill/>
-        </p:spPr>
-        <p:txBody>
-          <a:bodyPr wrap="square">
-            <a:spAutoFit/>
-          </a:bodyPr>
-          <a:lstStyle/>
-          <a:p>
-            <a:pPr algn="l">
-              <a:defRPr sz="1600" b="1">
-                <a:solidFill>
-                  <a:srgbClr val="0078D4"/>
-                </a:solidFill>
-                <a:latin typeface="Segoe UI"/>
-              </a:defRPr>
-            </a:pPr>
-            <a:r>
-              <a:t>Azure AI Blog</a:t>
-            </a:r>
-          </a:p>
-        </p:txBody>
-      </p:sp>
-      <p:sp>
-        <p:nvSpPr>
-          <p:cNvPr id="14" name="TextBox 13"/>
-          <p:cNvSpPr txBox="1"/>
-          <p:nvPr/>
-        </p:nvSpPr>
-        <p:spPr>
-          <a:xfrm>
-            <a:off x="4754880" y="3474720"/>
-            <a:ext cx="6858000" cy="365760"/>
-          </a:xfrm>
-          <a:prstGeom prst="rect">
-            <a:avLst/>
-          </a:prstGeom>
-          <a:noFill/>
-        </p:spPr>
-        <p:txBody>
-          <a:bodyPr wrap="square">
-            <a:spAutoFit/>
-          </a:bodyPr>
-          <a:lstStyle/>
-          <a:p>
-            <a:pPr algn="l">
-              <a:defRPr sz="1400" b="0">
-                <a:solidFill>
-                  <a:srgbClr val="CCCCCC"/>
-                </a:solidFill>
-                <a:latin typeface="Segoe UI"/>
-              </a:defRPr>
-            </a:pPr>
-            <a:r>
-              <a:t>https://azure.microsoft.com/en-us/blog/category/ai-machine-learning/</a:t>
-            </a:r>
-          </a:p>
-        </p:txBody>
-      </p:sp>
-      <p:sp>
-        <p:nvSpPr>
-          <p:cNvPr id="15" name="TextBox 14"/>
-          <p:cNvSpPr txBox="1"/>
-          <p:nvPr/>
-        </p:nvSpPr>
-        <p:spPr>
-          <a:xfrm>
-            <a:off x="914400" y="3977640"/>
-            <a:ext cx="3657600" cy="365760"/>
-          </a:xfrm>
-          <a:prstGeom prst="rect">
-            <a:avLst/>
-          </a:prstGeom>
-          <a:noFill/>
-        </p:spPr>
-        <p:txBody>
-          <a:bodyPr wrap="square">
-            <a:spAutoFit/>
-          </a:bodyPr>
-          <a:lstStyle/>
-          <a:p>
-            <a:pPr algn="l">
-              <a:defRPr sz="1600" b="1">
-                <a:solidFill>
-                  <a:srgbClr val="0078D4"/>
-                </a:solidFill>
-                <a:latin typeface="Segoe UI"/>
-              </a:defRPr>
-            </a:pPr>
-            <a:r>
-              <a:t>Foundry Tech Community</a:t>
-            </a:r>
-          </a:p>
-        </p:txBody>
-      </p:sp>
-      <p:sp>
-        <p:nvSpPr>
-          <p:cNvPr id="16" name="TextBox 15"/>
-          <p:cNvSpPr txBox="1"/>
-          <p:nvPr/>
-        </p:nvSpPr>
-        <p:spPr>
-          <a:xfrm>
-            <a:off x="4754880" y="3977640"/>
-            <a:ext cx="6858000" cy="365760"/>
-          </a:xfrm>
-          <a:prstGeom prst="rect">
-            <a:avLst/>
-          </a:prstGeom>
-          <a:noFill/>
-        </p:spPr>
-        <p:txBody>
-          <a:bodyPr wrap="square">
-            <a:spAutoFit/>
-          </a:bodyPr>
-          <a:lstStyle/>
-          <a:p>
-            <a:pPr algn="l">
-              <a:defRPr sz="1400" b="0">
-                <a:solidFill>
-                  <a:srgbClr val="CCCCCC"/>
-                </a:solidFill>
-                <a:latin typeface="Segoe UI"/>
-              </a:defRPr>
-            </a:pPr>
-            <a:r>
-              <a:t>https://techcommunity.microsoft.com/category/azure-ai-foundry/blog/azure-ai-foundry-blog/</a:t>
-            </a:r>
-          </a:p>
-        </p:txBody>
-      </p:sp>
-      <p:sp>
-        <p:nvSpPr>
-          <p:cNvPr id="17" name="TextBox 16"/>
-          <p:cNvSpPr txBox="1"/>
-          <p:nvPr/>
-        </p:nvSpPr>
-        <p:spPr>
-          <a:xfrm>
-            <a:off x="914400" y="4480560"/>
-            <a:ext cx="3657600" cy="365760"/>
-          </a:xfrm>
-          <a:prstGeom prst="rect">
-            <a:avLst/>
-          </a:prstGeom>
-          <a:noFill/>
-        </p:spPr>
-        <p:txBody>
-          <a:bodyPr wrap="square">
-            <a:spAutoFit/>
-          </a:bodyPr>
-          <a:lstStyle/>
-          <a:p>
-            <a:pPr algn="l">
-              <a:defRPr sz="1600" b="1">
-                <a:solidFill>
-                  <a:srgbClr val="0078D4"/>
-                </a:solidFill>
-                <a:latin typeface="Segoe UI"/>
-              </a:defRPr>
-            </a:pPr>
-            <a:r>
-              <a:t>Foundry Models Catalog</a:t>
-            </a:r>
-          </a:p>
-        </p:txBody>
-      </p:sp>
-      <p:sp>
-        <p:nvSpPr>
-          <p:cNvPr id="18" name="TextBox 17"/>
-          <p:cNvSpPr txBox="1"/>
-          <p:nvPr/>
-        </p:nvSpPr>
-        <p:spPr>
-          <a:xfrm>
-            <a:off x="4754880" y="4480560"/>
-            <a:ext cx="6858000" cy="365760"/>
-          </a:xfrm>
-          <a:prstGeom prst="rect">
-            <a:avLst/>
-          </a:prstGeom>
-          <a:noFill/>
-        </p:spPr>
-        <p:txBody>
-          <a:bodyPr wrap="square">
-            <a:spAutoFit/>
-          </a:bodyPr>
-          <a:lstStyle/>
-          <a:p>
-            <a:pPr algn="l">
-              <a:defRPr sz="1400" b="0">
-                <a:solidFill>
-                  <a:srgbClr val="CCCCCC"/>
-                </a:solidFill>
-                <a:latin typeface="Segoe UI"/>
-              </a:defRPr>
-            </a:pPr>
-            <a:r>
-              <a:t>https://azure.microsoft.com/en-us/products/ai-foundry/models/</a:t>
-            </a:r>
-          </a:p>
-        </p:txBody>
-      </p:sp>
-      <p:sp>
-        <p:nvSpPr>
-          <p:cNvPr id="19" name="TextBox 18"/>
-          <p:cNvSpPr txBox="1"/>
-          <p:nvPr/>
-        </p:nvSpPr>
-        <p:spPr>
-          <a:xfrm>
-            <a:off x="914400" y="4983480"/>
-            <a:ext cx="3657600" cy="365760"/>
-          </a:xfrm>
-          <a:prstGeom prst="rect">
-            <a:avLst/>
-          </a:prstGeom>
-          <a:noFill/>
-        </p:spPr>
-        <p:txBody>
-          <a:bodyPr wrap="square">
-            <a:spAutoFit/>
-          </a:bodyPr>
-          <a:lstStyle/>
-          <a:p>
-            <a:pPr algn="l">
-              <a:defRPr sz="1600" b="1">
-                <a:solidFill>
-                  <a:srgbClr val="0078D4"/>
-                </a:solidFill>
-                <a:latin typeface="Segoe UI"/>
-              </a:defRPr>
-            </a:pPr>
-            <a:r>
-              <a:t>Foundry Agent Service</a:t>
-            </a:r>
-          </a:p>
-        </p:txBody>
-      </p:sp>
-      <p:sp>
-        <p:nvSpPr>
-          <p:cNvPr id="20" name="TextBox 19"/>
-          <p:cNvSpPr txBox="1"/>
-          <p:nvPr/>
-        </p:nvSpPr>
-        <p:spPr>
-          <a:xfrm>
-            <a:off x="4754880" y="4983480"/>
-            <a:ext cx="6858000" cy="365760"/>
-          </a:xfrm>
-          <a:prstGeom prst="rect">
-            <a:avLst/>
-          </a:prstGeom>
-          <a:noFill/>
-        </p:spPr>
-        <p:txBody>
-          <a:bodyPr wrap="square">
-            <a:spAutoFit/>
-          </a:bodyPr>
-          <a:lstStyle/>
-          <a:p>
-            <a:pPr algn="l">
-              <a:defRPr sz="1400" b="0">
-                <a:solidFill>
-                  <a:srgbClr val="CCCCCC"/>
-                </a:solidFill>
-                <a:latin typeface="Segoe UI"/>
-              </a:defRPr>
-            </a:pPr>
-            <a:r>
-              <a:t>https://azure.microsoft.com/en-us/products/ai-foundry/agent-service/</a:t>
-            </a:r>
-          </a:p>
-        </p:txBody>
-      </p:sp>
-      <p:sp>
-        <p:nvSpPr>
-          <p:cNvPr id="21" name="TextBox 20"/>
-          <p:cNvSpPr txBox="1"/>
-          <p:nvPr/>
-        </p:nvSpPr>
-        <p:spPr>
-          <a:xfrm>
-            <a:off x="914400" y="5486400"/>
-            <a:ext cx="3657600" cy="365760"/>
-          </a:xfrm>
-          <a:prstGeom prst="rect">
-            <a:avLst/>
-          </a:prstGeom>
-          <a:noFill/>
-        </p:spPr>
-        <p:txBody>
-          <a:bodyPr wrap="square">
-            <a:spAutoFit/>
-          </a:bodyPr>
-          <a:lstStyle/>
-          <a:p>
-            <a:pPr algn="l">
-              <a:defRPr sz="1600" b="1">
-                <a:solidFill>
-                  <a:srgbClr val="0078D4"/>
-                </a:solidFill>
-                <a:latin typeface="Segoe UI"/>
-              </a:defRPr>
-            </a:pPr>
-            <a:r>
-              <a:t>Azure Updates Feed</a:t>
-            </a:r>
-          </a:p>
-        </p:txBody>
-      </p:sp>
-      <p:sp>
-        <p:nvSpPr>
-          <p:cNvPr id="22" name="TextBox 21"/>
-          <p:cNvSpPr txBox="1"/>
-          <p:nvPr/>
-        </p:nvSpPr>
-        <p:spPr>
-          <a:xfrm>
-            <a:off x="4754880" y="5486400"/>
-            <a:ext cx="6858000" cy="365760"/>
-          </a:xfrm>
-          <a:prstGeom prst="rect">
-            <a:avLst/>
-          </a:prstGeom>
-          <a:noFill/>
-        </p:spPr>
-        <p:txBody>
-          <a:bodyPr wrap="square">
-            <a:spAutoFit/>
-          </a:bodyPr>
-          <a:lstStyle/>
-          <a:p>
-            <a:pPr algn="l">
-              <a:defRPr sz="1400" b="0">
-                <a:solidFill>
-                  <a:srgbClr val="CCCCCC"/>
-                </a:solidFill>
-                <a:latin typeface="Segoe UI"/>
-              </a:defRPr>
-            </a:pPr>
-            <a:r>
-              <a:t>https://azure.microsoft.com/en-us/updates/</a:t>
-            </a:r>
-          </a:p>
-        </p:txBody>
-      </p:sp>
+        </p:nvGraphicFramePr>
+        <p:xfrm>
+          <a:off x="457200" y="1371600"/>
+          <a:ext cx="11247120" cy="4937760"/>
+        </p:xfrm>
+        <a:graphic>
+          <a:graphicData uri="http://schemas.openxmlformats.org/drawingml/2006/table">
+            <a:tbl>
+              <a:tblPr firstRow="1" bandRow="1">
+                <a:tableStyleId>{5C22544A-7EE6-4342-B048-85BDC9FD1C3A}</a:tableStyleId>
+              </a:tblPr>
+              <a:tblGrid>
+                <a:gridCol w="3200400"/>
+                <a:gridCol w="1828800"/>
+                <a:gridCol w="4572000"/>
+                <a:gridCol w="1645920"/>
+              </a:tblGrid>
+              <a:tr h="411480">
+                <a:tc>
+                  <a:txBody>
+                    <a:bodyPr/>
+                    <a:lstStyle/>
+                    <a:p>
+                      <a:pPr algn="l"/>
+                      <a:r>
+                        <a:rPr sz="1400" b="1">
+                          <a:solidFill>
+                            <a:srgbClr val="FFFFFF"/>
+                          </a:solidFill>
+                          <a:latin typeface="Segoe UI"/>
+                        </a:rPr>
+                        <a:t>Item</a:t>
+                      </a:r>
+                    </a:p>
+                  </a:txBody>
+                  <a:tcPr anchor="ctr">
+                    <a:solidFill>
+                      <a:srgbClr val="0078D4"/>
+                    </a:solidFill>
+                  </a:tcPr>
+                </a:tc>
+                <a:tc>
+                  <a:txBody>
+                    <a:bodyPr/>
+                    <a:lstStyle/>
+                    <a:p>
+                      <a:pPr algn="l"/>
+                      <a:r>
+                        <a:rPr sz="1400" b="1">
+                          <a:solidFill>
+                            <a:srgbClr val="FFFFFF"/>
+                          </a:solidFill>
+                          <a:latin typeface="Segoe UI"/>
+                        </a:rPr>
+                        <a:t>Category</a:t>
+                      </a:r>
+                    </a:p>
+                  </a:txBody>
+                  <a:tcPr anchor="ctr">
+                    <a:solidFill>
+                      <a:srgbClr val="0078D4"/>
+                    </a:solidFill>
+                  </a:tcPr>
+                </a:tc>
+                <a:tc>
+                  <a:txBody>
+                    <a:bodyPr/>
+                    <a:lstStyle/>
+                    <a:p>
+                      <a:pPr algn="l"/>
+                      <a:r>
+                        <a:rPr sz="1400" b="1">
+                          <a:solidFill>
+                            <a:srgbClr val="FFFFFF"/>
+                          </a:solidFill>
+                          <a:latin typeface="Segoe UI"/>
+                        </a:rPr>
+                        <a:t>Highlight</a:t>
+                      </a:r>
+                    </a:p>
+                  </a:txBody>
+                  <a:tcPr anchor="ctr">
+                    <a:solidFill>
+                      <a:srgbClr val="0078D4"/>
+                    </a:solidFill>
+                  </a:tcPr>
+                </a:tc>
+                <a:tc>
+                  <a:txBody>
+                    <a:bodyPr/>
+                    <a:lstStyle/>
+                    <a:p>
+                      <a:pPr algn="l"/>
+                      <a:r>
+                        <a:rPr sz="1400" b="1">
+                          <a:solidFill>
+                            <a:srgbClr val="FFFFFF"/>
+                          </a:solidFill>
+                          <a:latin typeface="Segoe UI"/>
+                        </a:rPr>
+                        <a:t>Date</a:t>
+                      </a:r>
+                    </a:p>
+                  </a:txBody>
+                  <a:tcPr anchor="ctr">
+                    <a:solidFill>
+                      <a:srgbClr val="0078D4"/>
+                    </a:solidFill>
+                  </a:tcPr>
+                </a:tc>
+              </a:tr>
+              <a:tr h="411480">
+                <a:tc>
+                  <a:txBody>
+                    <a:bodyPr/>
+                    <a:lstStyle/>
+                    <a:p>
+                      <a:pPr algn="l"/>
+                      <a:r>
+                        <a:rPr sz="1300" b="0">
+                          <a:solidFill>
+                            <a:srgbClr val="FFFFFF"/>
+                          </a:solidFill>
+                          <a:latin typeface="Segoe UI"/>
+                        </a:rPr>
+                        <a:t>Claude Sonnet 4.6</a:t>
+                      </a:r>
+                    </a:p>
+                  </a:txBody>
+                  <a:tcPr anchor="ctr">
+                    <a:solidFill>
+                      <a:srgbClr val="2A2A2A"/>
+                    </a:solidFill>
+                  </a:tcPr>
+                </a:tc>
+                <a:tc>
+                  <a:txBody>
+                    <a:bodyPr/>
+                    <a:lstStyle/>
+                    <a:p>
+                      <a:pPr algn="l"/>
+                      <a:r>
+                        <a:rPr sz="1300" b="0">
+                          <a:solidFill>
+                            <a:srgbClr val="FFFFFF"/>
+                          </a:solidFill>
+                          <a:latin typeface="Segoe UI"/>
+                        </a:rPr>
+                        <a:t>Model Release</a:t>
+                      </a:r>
+                    </a:p>
+                  </a:txBody>
+                  <a:tcPr anchor="ctr">
+                    <a:solidFill>
+                      <a:srgbClr val="2A2A2A"/>
+                    </a:solidFill>
+                  </a:tcPr>
+                </a:tc>
+                <a:tc>
+                  <a:txBody>
+                    <a:bodyPr/>
+                    <a:lstStyle/>
+                    <a:p>
+                      <a:pPr algn="l"/>
+                      <a:r>
+                        <a:rPr sz="1300" b="0">
+                          <a:solidFill>
+                            <a:srgbClr val="FFFFFF"/>
+                          </a:solidFill>
+                          <a:latin typeface="Segoe UI"/>
+                        </a:rPr>
+                        <a:t>Frontier performance for coding &amp; agents at scale</a:t>
+                      </a:r>
+                    </a:p>
+                  </a:txBody>
+                  <a:tcPr anchor="ctr">
+                    <a:solidFill>
+                      <a:srgbClr val="2A2A2A"/>
+                    </a:solidFill>
+                  </a:tcPr>
+                </a:tc>
+                <a:tc>
+                  <a:txBody>
+                    <a:bodyPr/>
+                    <a:lstStyle/>
+                    <a:p>
+                      <a:pPr algn="l"/>
+                      <a:r>
+                        <a:rPr sz="1300" b="0">
+                          <a:solidFill>
+                            <a:srgbClr val="FFFFFF"/>
+                          </a:solidFill>
+                          <a:latin typeface="Segoe UI"/>
+                        </a:rPr>
+                        <a:t>Feb 17</a:t>
+                      </a:r>
+                    </a:p>
+                  </a:txBody>
+                  <a:tcPr anchor="ctr">
+                    <a:solidFill>
+                      <a:srgbClr val="2A2A2A"/>
+                    </a:solidFill>
+                  </a:tcPr>
+                </a:tc>
+              </a:tr>
+              <a:tr h="411480">
+                <a:tc>
+                  <a:txBody>
+                    <a:bodyPr/>
+                    <a:lstStyle/>
+                    <a:p>
+                      <a:pPr algn="l"/>
+                      <a:r>
+                        <a:rPr sz="1300" b="0">
+                          <a:solidFill>
+                            <a:srgbClr val="FFFFFF"/>
+                          </a:solidFill>
+                          <a:latin typeface="Segoe UI"/>
+                        </a:rPr>
+                        <a:t>Claude Opus 4.6</a:t>
+                      </a:r>
+                    </a:p>
+                  </a:txBody>
+                  <a:tcPr anchor="ctr">
+                    <a:solidFill>
+                      <a:srgbClr val="222222"/>
+                    </a:solidFill>
+                  </a:tcPr>
+                </a:tc>
+                <a:tc>
+                  <a:txBody>
+                    <a:bodyPr/>
+                    <a:lstStyle/>
+                    <a:p>
+                      <a:pPr algn="l"/>
+                      <a:r>
+                        <a:rPr sz="1300" b="0">
+                          <a:solidFill>
+                            <a:srgbClr val="FFFFFF"/>
+                          </a:solidFill>
+                          <a:latin typeface="Segoe UI"/>
+                        </a:rPr>
+                        <a:t>Model Release</a:t>
+                      </a:r>
+                    </a:p>
+                  </a:txBody>
+                  <a:tcPr anchor="ctr">
+                    <a:solidFill>
+                      <a:srgbClr val="222222"/>
+                    </a:solidFill>
+                  </a:tcPr>
+                </a:tc>
+                <a:tc>
+                  <a:txBody>
+                    <a:bodyPr/>
+                    <a:lstStyle/>
+                    <a:p>
+                      <a:pPr algn="l"/>
+                      <a:r>
+                        <a:rPr sz="1300" b="0">
+                          <a:solidFill>
+                            <a:srgbClr val="FFFFFF"/>
+                          </a:solidFill>
+                          <a:latin typeface="Segoe UI"/>
+                        </a:rPr>
+                        <a:t>End-to-end autonomous task execution</a:t>
+                      </a:r>
+                    </a:p>
+                  </a:txBody>
+                  <a:tcPr anchor="ctr">
+                    <a:solidFill>
+                      <a:srgbClr val="222222"/>
+                    </a:solidFill>
+                  </a:tcPr>
+                </a:tc>
+                <a:tc>
+                  <a:txBody>
+                    <a:bodyPr/>
+                    <a:lstStyle/>
+                    <a:p>
+                      <a:pPr algn="l"/>
+                      <a:r>
+                        <a:rPr sz="1300" b="0">
+                          <a:solidFill>
+                            <a:srgbClr val="FFFFFF"/>
+                          </a:solidFill>
+                          <a:latin typeface="Segoe UI"/>
+                        </a:rPr>
+                        <a:t>Feb 5</a:t>
+                      </a:r>
+                    </a:p>
+                  </a:txBody>
+                  <a:tcPr anchor="ctr">
+                    <a:solidFill>
+                      <a:srgbClr val="222222"/>
+                    </a:solidFill>
+                  </a:tcPr>
+                </a:tc>
+              </a:tr>
+              <a:tr h="411480">
+                <a:tc>
+                  <a:txBody>
+                    <a:bodyPr/>
+                    <a:lstStyle/>
+                    <a:p>
+                      <a:pPr algn="l"/>
+                      <a:r>
+                        <a:rPr sz="1300" b="0">
+                          <a:solidFill>
+                            <a:srgbClr val="FFFFFF"/>
+                          </a:solidFill>
+                          <a:latin typeface="Segoe UI"/>
+                        </a:rPr>
+                        <a:t>PostgreSQL for AI</a:t>
+                      </a:r>
+                    </a:p>
+                  </a:txBody>
+                  <a:tcPr anchor="ctr">
+                    <a:solidFill>
+                      <a:srgbClr val="2A2A2A"/>
+                    </a:solidFill>
+                  </a:tcPr>
+                </a:tc>
+                <a:tc>
+                  <a:txBody>
+                    <a:bodyPr/>
+                    <a:lstStyle/>
+                    <a:p>
+                      <a:pPr algn="l"/>
+                      <a:r>
+                        <a:rPr sz="1300" b="0">
+                          <a:solidFill>
+                            <a:srgbClr val="FFFFFF"/>
+                          </a:solidFill>
+                          <a:latin typeface="Segoe UI"/>
+                        </a:rPr>
+                        <a:t>Data Service</a:t>
+                      </a:r>
+                    </a:p>
+                  </a:txBody>
+                  <a:tcPr anchor="ctr">
+                    <a:solidFill>
+                      <a:srgbClr val="2A2A2A"/>
+                    </a:solidFill>
+                  </a:tcPr>
+                </a:tc>
+                <a:tc>
+                  <a:txBody>
+                    <a:bodyPr/>
+                    <a:lstStyle/>
+                    <a:p>
+                      <a:pPr algn="l"/>
+                      <a:r>
+                        <a:rPr sz="1300" b="0">
+                          <a:solidFill>
+                            <a:srgbClr val="FFFFFF"/>
+                          </a:solidFill>
+                          <a:latin typeface="Segoe UI"/>
+                        </a:rPr>
+                        <a:t>DiskANN, MCP server, Copilot SQL, HorizonDB preview</a:t>
+                      </a:r>
+                    </a:p>
+                  </a:txBody>
+                  <a:tcPr anchor="ctr">
+                    <a:solidFill>
+                      <a:srgbClr val="2A2A2A"/>
+                    </a:solidFill>
+                  </a:tcPr>
+                </a:tc>
+                <a:tc>
+                  <a:txBody>
+                    <a:bodyPr/>
+                    <a:lstStyle/>
+                    <a:p>
+                      <a:pPr algn="l"/>
+                      <a:r>
+                        <a:rPr sz="1300" b="0">
+                          <a:solidFill>
+                            <a:srgbClr val="FFFFFF"/>
+                          </a:solidFill>
+                          <a:latin typeface="Segoe UI"/>
+                        </a:rPr>
+                        <a:t>Feb 2</a:t>
+                      </a:r>
+                    </a:p>
+                  </a:txBody>
+                  <a:tcPr anchor="ctr">
+                    <a:solidFill>
+                      <a:srgbClr val="2A2A2A"/>
+                    </a:solidFill>
+                  </a:tcPr>
+                </a:tc>
+              </a:tr>
+              <a:tr h="411480">
+                <a:tc>
+                  <a:txBody>
+                    <a:bodyPr/>
+                    <a:lstStyle/>
+                    <a:p>
+                      <a:pPr algn="l"/>
+                      <a:r>
+                        <a:rPr sz="1300" b="0">
+                          <a:solidFill>
+                            <a:srgbClr val="FFFFFF"/>
+                          </a:solidFill>
+                          <a:latin typeface="Segoe UI"/>
+                        </a:rPr>
+                        <a:t>High-Temp Superconductors</a:t>
+                      </a:r>
+                    </a:p>
+                  </a:txBody>
+                  <a:tcPr anchor="ctr">
+                    <a:solidFill>
+                      <a:srgbClr val="222222"/>
+                    </a:solidFill>
+                  </a:tcPr>
+                </a:tc>
+                <a:tc>
+                  <a:txBody>
+                    <a:bodyPr/>
+                    <a:lstStyle/>
+                    <a:p>
+                      <a:pPr algn="l"/>
+                      <a:r>
+                        <a:rPr sz="1300" b="0">
+                          <a:solidFill>
+                            <a:srgbClr val="FFFFFF"/>
+                          </a:solidFill>
+                          <a:latin typeface="Segoe UI"/>
+                        </a:rPr>
+                        <a:t>Infrastructure</a:t>
+                      </a:r>
+                    </a:p>
+                  </a:txBody>
+                  <a:tcPr anchor="ctr">
+                    <a:solidFill>
+                      <a:srgbClr val="222222"/>
+                    </a:solidFill>
+                  </a:tcPr>
+                </a:tc>
+                <a:tc>
+                  <a:txBody>
+                    <a:bodyPr/>
+                    <a:lstStyle/>
+                    <a:p>
+                      <a:pPr algn="l"/>
+                      <a:r>
+                        <a:rPr sz="1300" b="0">
+                          <a:solidFill>
+                            <a:srgbClr val="FFFFFF"/>
+                          </a:solidFill>
+                          <a:latin typeface="Segoe UI"/>
+                        </a:rPr>
+                        <a:t>Exploring superconductors for datacenter power</a:t>
+                      </a:r>
+                    </a:p>
+                  </a:txBody>
+                  <a:tcPr anchor="ctr">
+                    <a:solidFill>
+                      <a:srgbClr val="222222"/>
+                    </a:solidFill>
+                  </a:tcPr>
+                </a:tc>
+                <a:tc>
+                  <a:txBody>
+                    <a:bodyPr/>
+                    <a:lstStyle/>
+                    <a:p>
+                      <a:pPr algn="l"/>
+                      <a:r>
+                        <a:rPr sz="1300" b="0">
+                          <a:solidFill>
+                            <a:srgbClr val="FFFFFF"/>
+                          </a:solidFill>
+                          <a:latin typeface="Segoe UI"/>
+                        </a:rPr>
+                        <a:t>Feb 10</a:t>
+                      </a:r>
+                    </a:p>
+                  </a:txBody>
+                  <a:tcPr anchor="ctr">
+                    <a:solidFill>
+                      <a:srgbClr val="222222"/>
+                    </a:solidFill>
+                  </a:tcPr>
+                </a:tc>
+              </a:tr>
+              <a:tr h="411480">
+                <a:tc>
+                  <a:txBody>
+                    <a:bodyPr/>
+                    <a:lstStyle/>
+                    <a:p>
+                      <a:pPr algn="l"/>
+                      <a:r>
+                        <a:rPr sz="1300" b="0">
+                          <a:solidFill>
+                            <a:srgbClr val="FFFFFF"/>
+                          </a:solidFill>
+                          <a:latin typeface="Segoe UI"/>
+                        </a:rPr>
+                        <a:t>Agentic Cloud Ops</a:t>
+                      </a:r>
+                    </a:p>
+                  </a:txBody>
+                  <a:tcPr anchor="ctr">
+                    <a:solidFill>
+                      <a:srgbClr val="2A2A2A"/>
+                    </a:solidFill>
+                  </a:tcPr>
+                </a:tc>
+                <a:tc>
+                  <a:txBody>
+                    <a:bodyPr/>
+                    <a:lstStyle/>
+                    <a:p>
+                      <a:pPr algn="l"/>
+                      <a:r>
+                        <a:rPr sz="1300" b="0">
+                          <a:solidFill>
+                            <a:srgbClr val="FFFFFF"/>
+                          </a:solidFill>
+                          <a:latin typeface="Segoe UI"/>
+                        </a:rPr>
+                        <a:t>Framework</a:t>
+                      </a:r>
+                    </a:p>
+                  </a:txBody>
+                  <a:tcPr anchor="ctr">
+                    <a:solidFill>
+                      <a:srgbClr val="2A2A2A"/>
+                    </a:solidFill>
+                  </a:tcPr>
+                </a:tc>
+                <a:tc>
+                  <a:txBody>
+                    <a:bodyPr/>
+                    <a:lstStyle/>
+                    <a:p>
+                      <a:pPr algn="l"/>
+                      <a:r>
+                        <a:rPr sz="1300" b="0">
+                          <a:solidFill>
+                            <a:srgbClr val="FFFFFF"/>
+                          </a:solidFill>
+                          <a:latin typeface="Segoe UI"/>
+                        </a:rPr>
+                        <a:t>AI agents for cloud operations &amp; incident response</a:t>
+                      </a:r>
+                    </a:p>
+                  </a:txBody>
+                  <a:tcPr anchor="ctr">
+                    <a:solidFill>
+                      <a:srgbClr val="2A2A2A"/>
+                    </a:solidFill>
+                  </a:tcPr>
+                </a:tc>
+                <a:tc>
+                  <a:txBody>
+                    <a:bodyPr/>
+                    <a:lstStyle/>
+                    <a:p>
+                      <a:pPr algn="l"/>
+                      <a:r>
+                        <a:rPr sz="1300" b="0">
+                          <a:solidFill>
+                            <a:srgbClr val="FFFFFF"/>
+                          </a:solidFill>
+                          <a:latin typeface="Segoe UI"/>
+                        </a:rPr>
+                        <a:t>Feb 11</a:t>
+                      </a:r>
+                    </a:p>
+                  </a:txBody>
+                  <a:tcPr anchor="ctr">
+                    <a:solidFill>
+                      <a:srgbClr val="2A2A2A"/>
+                    </a:solidFill>
+                  </a:tcPr>
+                </a:tc>
+              </a:tr>
+              <a:tr h="411480">
+                <a:tc>
+                  <a:txBody>
+                    <a:bodyPr/>
+                    <a:lstStyle/>
+                    <a:p>
+                      <a:pPr algn="l"/>
+                      <a:r>
+                        <a:rPr sz="1300" b="0">
+                          <a:solidFill>
+                            <a:srgbClr val="FFFFFF"/>
+                          </a:solidFill>
+                          <a:latin typeface="Segoe UI"/>
+                        </a:rPr>
+                        <a:t>Pantone Case Study</a:t>
+                      </a:r>
+                    </a:p>
+                  </a:txBody>
+                  <a:tcPr anchor="ctr">
+                    <a:solidFill>
+                      <a:srgbClr val="222222"/>
+                    </a:solidFill>
+                  </a:tcPr>
+                </a:tc>
+                <a:tc>
+                  <a:txBody>
+                    <a:bodyPr/>
+                    <a:lstStyle/>
+                    <a:p>
+                      <a:pPr algn="l"/>
+                      <a:r>
+                        <a:rPr sz="1300" b="0">
+                          <a:solidFill>
+                            <a:srgbClr val="FFFFFF"/>
+                          </a:solidFill>
+                          <a:latin typeface="Segoe UI"/>
+                        </a:rPr>
+                        <a:t>Ecosystem</a:t>
+                      </a:r>
+                    </a:p>
+                  </a:txBody>
+                  <a:tcPr anchor="ctr">
+                    <a:solidFill>
+                      <a:srgbClr val="222222"/>
+                    </a:solidFill>
+                  </a:tcPr>
+                </a:tc>
+                <a:tc>
+                  <a:txBody>
+                    <a:bodyPr/>
+                    <a:lstStyle/>
+                    <a:p>
+                      <a:pPr algn="l"/>
+                      <a:r>
+                        <a:rPr sz="1300" b="0">
+                          <a:solidFill>
+                            <a:srgbClr val="FFFFFF"/>
+                          </a:solidFill>
+                          <a:latin typeface="Segoe UI"/>
+                        </a:rPr>
+                        <a:t>Agentic AI + AI-ready database in production</a:t>
+                      </a:r>
+                    </a:p>
+                  </a:txBody>
+                  <a:tcPr anchor="ctr">
+                    <a:solidFill>
+                      <a:srgbClr val="222222"/>
+                    </a:solidFill>
+                  </a:tcPr>
+                </a:tc>
+                <a:tc>
+                  <a:txBody>
+                    <a:bodyPr/>
+                    <a:lstStyle/>
+                    <a:p>
+                      <a:pPr algn="l"/>
+                      <a:r>
+                        <a:rPr sz="1300" b="0">
+                          <a:solidFill>
+                            <a:srgbClr val="FFFFFF"/>
+                          </a:solidFill>
+                          <a:latin typeface="Segoe UI"/>
+                        </a:rPr>
+                        <a:t>Feb 12</a:t>
+                      </a:r>
+                    </a:p>
+                  </a:txBody>
+                  <a:tcPr anchor="ctr">
+                    <a:solidFill>
+                      <a:srgbClr val="222222"/>
+                    </a:solidFill>
+                  </a:tcPr>
+                </a:tc>
+              </a:tr>
+              <a:tr h="411480">
+                <a:tc>
+                  <a:txBody>
+                    <a:bodyPr/>
+                    <a:lstStyle/>
+                    <a:p>
+                      <a:pPr algn="l"/>
+                      <a:r>
+                        <a:rPr sz="1300" b="0">
+                          <a:solidFill>
+                            <a:srgbClr val="FFFFFF"/>
+                          </a:solidFill>
+                          <a:latin typeface="Segoe UI"/>
+                        </a:rPr>
+                        <a:t>Agents League</a:t>
+                      </a:r>
+                    </a:p>
+                  </a:txBody>
+                  <a:tcPr anchor="ctr">
+                    <a:solidFill>
+                      <a:srgbClr val="2A2A2A"/>
+                    </a:solidFill>
+                  </a:tcPr>
+                </a:tc>
+                <a:tc>
+                  <a:txBody>
+                    <a:bodyPr/>
+                    <a:lstStyle/>
+                    <a:p>
+                      <a:pPr algn="l"/>
+                      <a:r>
+                        <a:rPr sz="1300" b="0">
+                          <a:solidFill>
+                            <a:srgbClr val="FFFFFF"/>
+                          </a:solidFill>
+                          <a:latin typeface="Segoe UI"/>
+                        </a:rPr>
+                        <a:t>Community</a:t>
+                      </a:r>
+                    </a:p>
+                  </a:txBody>
+                  <a:tcPr anchor="ctr">
+                    <a:solidFill>
+                      <a:srgbClr val="2A2A2A"/>
+                    </a:solidFill>
+                  </a:tcPr>
+                </a:tc>
+                <a:tc>
+                  <a:txBody>
+                    <a:bodyPr/>
+                    <a:lstStyle/>
+                    <a:p>
+                      <a:pPr algn="l"/>
+                      <a:r>
+                        <a:rPr sz="1300" b="0">
+                          <a:solidFill>
+                            <a:srgbClr val="FFFFFF"/>
+                          </a:solidFill>
+                          <a:latin typeface="Segoe UI"/>
+                        </a:rPr>
+                        <a:t>Developer challenge for building AI agents</a:t>
+                      </a:r>
+                    </a:p>
+                  </a:txBody>
+                  <a:tcPr anchor="ctr">
+                    <a:solidFill>
+                      <a:srgbClr val="2A2A2A"/>
+                    </a:solidFill>
+                  </a:tcPr>
+                </a:tc>
+                <a:tc>
+                  <a:txBody>
+                    <a:bodyPr/>
+                    <a:lstStyle/>
+                    <a:p>
+                      <a:pPr algn="l"/>
+                      <a:r>
+                        <a:rPr sz="1300" b="0">
+                          <a:solidFill>
+                            <a:srgbClr val="FFFFFF"/>
+                          </a:solidFill>
+                          <a:latin typeface="Segoe UI"/>
+                        </a:rPr>
+                        <a:t>Feb 16–27</a:t>
+                      </a:r>
+                    </a:p>
+                  </a:txBody>
+                  <a:tcPr anchor="ctr">
+                    <a:solidFill>
+                      <a:srgbClr val="2A2A2A"/>
+                    </a:solidFill>
+                  </a:tcPr>
+                </a:tc>
+              </a:tr>
+              <a:tr h="411480">
+                <a:tc>
+                  <a:txBody>
+                    <a:bodyPr/>
+                    <a:lstStyle/>
+                    <a:p>
+                      <a:pPr algn="l"/>
+                      <a:r>
+                        <a:rPr sz="1300" b="0">
+                          <a:solidFill>
+                            <a:srgbClr val="FFFFFF"/>
+                          </a:solidFill>
+                          <a:latin typeface="Segoe UI"/>
+                        </a:rPr>
+                        <a:t>Agent Framework RC</a:t>
+                      </a:r>
+                    </a:p>
+                  </a:txBody>
+                  <a:tcPr anchor="ctr">
+                    <a:solidFill>
+                      <a:srgbClr val="222222"/>
+                    </a:solidFill>
+                  </a:tcPr>
+                </a:tc>
+                <a:tc>
+                  <a:txBody>
+                    <a:bodyPr/>
+                    <a:lstStyle/>
+                    <a:p>
+                      <a:pPr algn="l"/>
+                      <a:r>
+                        <a:rPr sz="1300" b="0">
+                          <a:solidFill>
+                            <a:srgbClr val="FFFFFF"/>
+                          </a:solidFill>
+                          <a:latin typeface="Segoe UI"/>
+                        </a:rPr>
+                        <a:t>Foundry Blog</a:t>
+                      </a:r>
+                    </a:p>
+                  </a:txBody>
+                  <a:tcPr anchor="ctr">
+                    <a:solidFill>
+                      <a:srgbClr val="222222"/>
+                    </a:solidFill>
+                  </a:tcPr>
+                </a:tc>
+                <a:tc>
+                  <a:txBody>
+                    <a:bodyPr/>
+                    <a:lstStyle/>
+                    <a:p>
+                      <a:pPr algn="l"/>
+                      <a:r>
+                        <a:rPr sz="1300" b="0">
+                          <a:solidFill>
+                            <a:srgbClr val="FFFFFF"/>
+                          </a:solidFill>
+                          <a:latin typeface="Segoe UI"/>
+                        </a:rPr>
+                        <a:t>Successor to SK &amp; AutoGen hits Release Candidate</a:t>
+                      </a:r>
+                    </a:p>
+                  </a:txBody>
+                  <a:tcPr anchor="ctr">
+                    <a:solidFill>
+                      <a:srgbClr val="222222"/>
+                    </a:solidFill>
+                  </a:tcPr>
+                </a:tc>
+                <a:tc>
+                  <a:txBody>
+                    <a:bodyPr/>
+                    <a:lstStyle/>
+                    <a:p>
+                      <a:pPr algn="l"/>
+                      <a:r>
+                        <a:rPr sz="1300" b="0">
+                          <a:solidFill>
+                            <a:srgbClr val="FFFFFF"/>
+                          </a:solidFill>
+                          <a:latin typeface="Segoe UI"/>
+                        </a:rPr>
+                        <a:t>Feb 19</a:t>
+                      </a:r>
+                    </a:p>
+                  </a:txBody>
+                  <a:tcPr anchor="ctr">
+                    <a:solidFill>
+                      <a:srgbClr val="222222"/>
+                    </a:solidFill>
+                  </a:tcPr>
+                </a:tc>
+              </a:tr>
+              <a:tr h="411480">
+                <a:tc>
+                  <a:txBody>
+                    <a:bodyPr/>
+                    <a:lstStyle/>
+                    <a:p>
+                      <a:pPr algn="l"/>
+                      <a:r>
+                        <a:rPr sz="1300" b="0">
+                          <a:solidFill>
+                            <a:srgbClr val="FFFFFF"/>
+                          </a:solidFill>
+                          <a:latin typeface="Segoe UI"/>
+                        </a:rPr>
+                        <a:t>Foundry What’s New</a:t>
+                      </a:r>
+                    </a:p>
+                  </a:txBody>
+                  <a:tcPr anchor="ctr">
+                    <a:solidFill>
+                      <a:srgbClr val="2A2A2A"/>
+                    </a:solidFill>
+                  </a:tcPr>
+                </a:tc>
+                <a:tc>
+                  <a:txBody>
+                    <a:bodyPr/>
+                    <a:lstStyle/>
+                    <a:p>
+                      <a:pPr algn="l"/>
+                      <a:r>
+                        <a:rPr sz="1300" b="0">
+                          <a:solidFill>
+                            <a:srgbClr val="FFFFFF"/>
+                          </a:solidFill>
+                          <a:latin typeface="Segoe UI"/>
+                        </a:rPr>
+                        <a:t>Foundry Blog</a:t>
+                      </a:r>
+                    </a:p>
+                  </a:txBody>
+                  <a:tcPr anchor="ctr">
+                    <a:solidFill>
+                      <a:srgbClr val="2A2A2A"/>
+                    </a:solidFill>
+                  </a:tcPr>
+                </a:tc>
+                <a:tc>
+                  <a:txBody>
+                    <a:bodyPr/>
+                    <a:lstStyle/>
+                    <a:p>
+                      <a:pPr algn="l"/>
+                      <a:r>
+                        <a:rPr sz="1300" b="0">
+                          <a:solidFill>
+                            <a:srgbClr val="FFFFFF"/>
+                          </a:solidFill>
+                          <a:latin typeface="Segoe UI"/>
+                        </a:rPr>
+                        <a:t>GPT-5.2, Codex Max, A2A, Memory, MCP roundup</a:t>
+                      </a:r>
+                    </a:p>
+                  </a:txBody>
+                  <a:tcPr anchor="ctr">
+                    <a:solidFill>
+                      <a:srgbClr val="2A2A2A"/>
+                    </a:solidFill>
+                  </a:tcPr>
+                </a:tc>
+                <a:tc>
+                  <a:txBody>
+                    <a:bodyPr/>
+                    <a:lstStyle/>
+                    <a:p>
+                      <a:pPr algn="l"/>
+                      <a:r>
+                        <a:rPr sz="1300" b="0">
+                          <a:solidFill>
+                            <a:srgbClr val="FFFFFF"/>
+                          </a:solidFill>
+                          <a:latin typeface="Segoe UI"/>
+                        </a:rPr>
+                        <a:t>Feb 18</a:t>
+                      </a:r>
+                    </a:p>
+                  </a:txBody>
+                  <a:tcPr anchor="ctr">
+                    <a:solidFill>
+                      <a:srgbClr val="2A2A2A"/>
+                    </a:solidFill>
+                  </a:tcPr>
+                </a:tc>
+              </a:tr>
+              <a:tr h="411480">
+                <a:tc>
+                  <a:txBody>
+                    <a:bodyPr/>
+                    <a:lstStyle/>
+                    <a:p>
+                      <a:pPr algn="l"/>
+                      <a:r>
+                        <a:rPr sz="1300" b="0">
+                          <a:solidFill>
+                            <a:srgbClr val="FFFFFF"/>
+                          </a:solidFill>
+                          <a:latin typeface="Segoe UI"/>
+                        </a:rPr>
+                        <a:t>DPO Fine-Tuning Guide</a:t>
+                      </a:r>
+                    </a:p>
+                  </a:txBody>
+                  <a:tcPr anchor="ctr">
+                    <a:solidFill>
+                      <a:srgbClr val="222222"/>
+                    </a:solidFill>
+                  </a:tcPr>
+                </a:tc>
+                <a:tc>
+                  <a:txBody>
+                    <a:bodyPr/>
+                    <a:lstStyle/>
+                    <a:p>
+                      <a:pPr algn="l"/>
+                      <a:r>
+                        <a:rPr sz="1300" b="0">
+                          <a:solidFill>
+                            <a:srgbClr val="FFFFFF"/>
+                          </a:solidFill>
+                          <a:latin typeface="Segoe UI"/>
+                        </a:rPr>
+                        <a:t>Foundry Blog</a:t>
+                      </a:r>
+                    </a:p>
+                  </a:txBody>
+                  <a:tcPr anchor="ctr">
+                    <a:solidFill>
+                      <a:srgbClr val="222222"/>
+                    </a:solidFill>
+                  </a:tcPr>
+                </a:tc>
+                <a:tc>
+                  <a:txBody>
+                    <a:bodyPr/>
+                    <a:lstStyle/>
+                    <a:p>
+                      <a:pPr algn="l"/>
+                      <a:r>
+                        <a:rPr sz="1300" b="0">
+                          <a:solidFill>
+                            <a:srgbClr val="FFFFFF"/>
+                          </a:solidFill>
+                          <a:latin typeface="Segoe UI"/>
+                        </a:rPr>
+                        <a:t>DPO walkthrough using Foundry SDK</a:t>
+                      </a:r>
+                    </a:p>
+                  </a:txBody>
+                  <a:tcPr anchor="ctr">
+                    <a:solidFill>
+                      <a:srgbClr val="222222"/>
+                    </a:solidFill>
+                  </a:tcPr>
+                </a:tc>
+                <a:tc>
+                  <a:txBody>
+                    <a:bodyPr/>
+                    <a:lstStyle/>
+                    <a:p>
+                      <a:pPr algn="l"/>
+                      <a:r>
+                        <a:rPr sz="1300" b="0">
+                          <a:solidFill>
+                            <a:srgbClr val="FFFFFF"/>
+                          </a:solidFill>
+                          <a:latin typeface="Segoe UI"/>
+                        </a:rPr>
+                        <a:t>Feb 13</a:t>
+                      </a:r>
+                    </a:p>
+                  </a:txBody>
+                  <a:tcPr anchor="ctr">
+                    <a:solidFill>
+                      <a:srgbClr val="222222"/>
+                    </a:solidFill>
+                  </a:tcPr>
+                </a:tc>
+              </a:tr>
+              <a:tr h="411480">
+                <a:tc>
+                  <a:txBody>
+                    <a:bodyPr/>
+                    <a:lstStyle/>
+                    <a:p>
+                      <a:pPr algn="l"/>
+                      <a:r>
+                        <a:rPr sz="1300" b="0">
+                          <a:solidFill>
+                            <a:srgbClr val="FFFFFF"/>
+                          </a:solidFill>
+                          <a:latin typeface="Segoe UI"/>
+                        </a:rPr>
+                        <a:t>Fine-Tuning Guide</a:t>
+                      </a:r>
+                    </a:p>
+                  </a:txBody>
+                  <a:tcPr anchor="ctr">
+                    <a:solidFill>
+                      <a:srgbClr val="2A2A2A"/>
+                    </a:solidFill>
+                  </a:tcPr>
+                </a:tc>
+                <a:tc>
+                  <a:txBody>
+                    <a:bodyPr/>
+                    <a:lstStyle/>
+                    <a:p>
+                      <a:pPr algn="l"/>
+                      <a:r>
+                        <a:rPr sz="1300" b="0">
+                          <a:solidFill>
+                            <a:srgbClr val="FFFFFF"/>
+                          </a:solidFill>
+                          <a:latin typeface="Segoe UI"/>
+                        </a:rPr>
+                        <a:t>Foundry Blog</a:t>
+                      </a:r>
+                    </a:p>
+                  </a:txBody>
+                  <a:tcPr anchor="ctr">
+                    <a:solidFill>
+                      <a:srgbClr val="2A2A2A"/>
+                    </a:solidFill>
+                  </a:tcPr>
+                </a:tc>
+                <a:tc>
+                  <a:txBody>
+                    <a:bodyPr/>
+                    <a:lstStyle/>
+                    <a:p>
+                      <a:pPr algn="l"/>
+                      <a:r>
+                        <a:rPr sz="1300" b="0">
+                          <a:solidFill>
+                            <a:srgbClr val="FFFFFF"/>
+                          </a:solidFill>
+                          <a:latin typeface="Segoe UI"/>
+                        </a:rPr>
+                        <a:t>When &amp; how to move beyond prompting</a:t>
+                      </a:r>
+                    </a:p>
+                  </a:txBody>
+                  <a:tcPr anchor="ctr">
+                    <a:solidFill>
+                      <a:srgbClr val="2A2A2A"/>
+                    </a:solidFill>
+                  </a:tcPr>
+                </a:tc>
+                <a:tc>
+                  <a:txBody>
+                    <a:bodyPr/>
+                    <a:lstStyle/>
+                    <a:p>
+                      <a:pPr algn="l"/>
+                      <a:r>
+                        <a:rPr sz="1300" b="0">
+                          <a:solidFill>
+                            <a:srgbClr val="FFFFFF"/>
+                          </a:solidFill>
+                          <a:latin typeface="Segoe UI"/>
+                        </a:rPr>
+                        <a:t>Feb 6</a:t>
+                      </a:r>
+                    </a:p>
+                  </a:txBody>
+                  <a:tcPr anchor="ctr">
+                    <a:solidFill>
+                      <a:srgbClr val="2A2A2A"/>
+                    </a:solidFill>
+                  </a:tcPr>
+                </a:tc>
+              </a:tr>
+            </a:tbl>
+          </a:graphicData>
+        </a:graphic>
+      </p:graphicFrame>
     </p:spTree>
   </p:cSld>
   <p:clrMapOvr>
@@ -4166,6 +4675,874 @@
         </p:nvSpPr>
         <p:spPr>
           <a:xfrm>
+            <a:off x="731520" y="365760"/>
+            <a:ext cx="10058400" cy="640080"/>
+          </a:xfrm>
+          <a:prstGeom prst="rect">
+            <a:avLst/>
+          </a:prstGeom>
+          <a:noFill/>
+        </p:spPr>
+        <p:txBody>
+          <a:bodyPr wrap="square">
+            <a:spAutoFit/>
+          </a:bodyPr>
+          <a:lstStyle/>
+          <a:p>
+            <a:pPr algn="l">
+              <a:defRPr sz="3400" b="1">
+                <a:solidFill>
+                  <a:srgbClr val="FFFFFF"/>
+                </a:solidFill>
+                <a:latin typeface="Segoe UI"/>
+              </a:defRPr>
+            </a:pPr>
+            <a:r>
+              <a:t>Key Links &amp; Resources</a:t>
+            </a:r>
+          </a:p>
+        </p:txBody>
+      </p:sp>
+      <p:sp>
+        <p:nvSpPr>
+          <p:cNvPr id="4" name="Rectangle 3"/>
+          <p:cNvSpPr/>
+          <p:nvPr/>
+        </p:nvSpPr>
+        <p:spPr>
+          <a:xfrm>
+            <a:off x="457200" y="1005840"/>
+            <a:ext cx="1097280" cy="50800"/>
+          </a:xfrm>
+          <a:prstGeom prst="rect">
+            <a:avLst/>
+          </a:prstGeom>
+          <a:solidFill>
+            <a:srgbClr val="0078D4"/>
+          </a:solidFill>
+          <a:ln>
+            <a:noFill/>
+          </a:ln>
+        </p:spPr>
+        <p:style>
+          <a:lnRef idx="1">
+            <a:schemeClr val="accent1"/>
+          </a:lnRef>
+          <a:fillRef idx="3">
+            <a:schemeClr val="accent1"/>
+          </a:fillRef>
+          <a:effectRef idx="2">
+            <a:schemeClr val="accent1"/>
+          </a:effectRef>
+          <a:fontRef idx="minor">
+            <a:schemeClr val="lt1"/>
+          </a:fontRef>
+        </p:style>
+        <p:txBody>
+          <a:bodyPr rtlCol="0" anchor="ctr"/>
+          <a:lstStyle/>
+          <a:p>
+            <a:pPr algn="ctr"/>
+          </a:p>
+        </p:txBody>
+      </p:sp>
+      <p:sp>
+        <p:nvSpPr>
+          <p:cNvPr id="5" name="TextBox 4"/>
+          <p:cNvSpPr txBox="1"/>
+          <p:nvPr/>
+        </p:nvSpPr>
+        <p:spPr>
+          <a:xfrm>
+            <a:off x="914400" y="1463040"/>
+            <a:ext cx="3657600" cy="365760"/>
+          </a:xfrm>
+          <a:prstGeom prst="rect">
+            <a:avLst/>
+          </a:prstGeom>
+          <a:noFill/>
+        </p:spPr>
+        <p:txBody>
+          <a:bodyPr wrap="square">
+            <a:spAutoFit/>
+          </a:bodyPr>
+          <a:lstStyle/>
+          <a:p>
+            <a:pPr algn="l">
+              <a:defRPr sz="1600" b="1">
+                <a:solidFill>
+                  <a:srgbClr val="0078D4"/>
+                </a:solidFill>
+                <a:latin typeface="Segoe UI"/>
+              </a:defRPr>
+            </a:pPr>
+            <a:r>
+              <a:t>Microsoft Foundry Portal</a:t>
+            </a:r>
+          </a:p>
+        </p:txBody>
+      </p:sp>
+      <p:sp>
+        <p:nvSpPr>
+          <p:cNvPr id="6" name="TextBox 5"/>
+          <p:cNvSpPr txBox="1"/>
+          <p:nvPr/>
+        </p:nvSpPr>
+        <p:spPr>
+          <a:xfrm>
+            <a:off x="4754880" y="1463040"/>
+            <a:ext cx="6858000" cy="365760"/>
+          </a:xfrm>
+          <a:prstGeom prst="rect">
+            <a:avLst/>
+          </a:prstGeom>
+          <a:noFill/>
+        </p:spPr>
+        <p:txBody>
+          <a:bodyPr wrap="square">
+            <a:spAutoFit/>
+          </a:bodyPr>
+          <a:lstStyle/>
+          <a:p>
+            <a:pPr algn="l">
+              <a:defRPr sz="1400" b="0">
+                <a:solidFill>
+                  <a:srgbClr val="CCCCCC"/>
+                </a:solidFill>
+                <a:latin typeface="Segoe UI"/>
+              </a:defRPr>
+            </a:pPr>
+            <a:r>
+              <a:t>https://ai.azure.com/</a:t>
+            </a:r>
+          </a:p>
+        </p:txBody>
+      </p:sp>
+      <p:sp>
+        <p:nvSpPr>
+          <p:cNvPr id="7" name="TextBox 6"/>
+          <p:cNvSpPr txBox="1"/>
+          <p:nvPr/>
+        </p:nvSpPr>
+        <p:spPr>
+          <a:xfrm>
+            <a:off x="914400" y="1965960"/>
+            <a:ext cx="3657600" cy="365760"/>
+          </a:xfrm>
+          <a:prstGeom prst="rect">
+            <a:avLst/>
+          </a:prstGeom>
+          <a:noFill/>
+        </p:spPr>
+        <p:txBody>
+          <a:bodyPr wrap="square">
+            <a:spAutoFit/>
+          </a:bodyPr>
+          <a:lstStyle/>
+          <a:p>
+            <a:pPr algn="l">
+              <a:defRPr sz="1600" b="1">
+                <a:solidFill>
+                  <a:srgbClr val="0078D4"/>
+                </a:solidFill>
+                <a:latin typeface="Segoe UI"/>
+              </a:defRPr>
+            </a:pPr>
+            <a:r>
+              <a:t>Foundry Product Page</a:t>
+            </a:r>
+          </a:p>
+        </p:txBody>
+      </p:sp>
+      <p:sp>
+        <p:nvSpPr>
+          <p:cNvPr id="8" name="TextBox 7"/>
+          <p:cNvSpPr txBox="1"/>
+          <p:nvPr/>
+        </p:nvSpPr>
+        <p:spPr>
+          <a:xfrm>
+            <a:off x="4754880" y="1965960"/>
+            <a:ext cx="6858000" cy="365760"/>
+          </a:xfrm>
+          <a:prstGeom prst="rect">
+            <a:avLst/>
+          </a:prstGeom>
+          <a:noFill/>
+        </p:spPr>
+        <p:txBody>
+          <a:bodyPr wrap="square">
+            <a:spAutoFit/>
+          </a:bodyPr>
+          <a:lstStyle/>
+          <a:p>
+            <a:pPr algn="l">
+              <a:defRPr sz="1400" b="0">
+                <a:solidFill>
+                  <a:srgbClr val="CCCCCC"/>
+                </a:solidFill>
+                <a:latin typeface="Segoe UI"/>
+              </a:defRPr>
+            </a:pPr>
+            <a:r>
+              <a:t>https://azure.microsoft.com/en-us/products/ai-foundry/</a:t>
+            </a:r>
+          </a:p>
+        </p:txBody>
+      </p:sp>
+      <p:sp>
+        <p:nvSpPr>
+          <p:cNvPr id="9" name="TextBox 8"/>
+          <p:cNvSpPr txBox="1"/>
+          <p:nvPr/>
+        </p:nvSpPr>
+        <p:spPr>
+          <a:xfrm>
+            <a:off x="914400" y="2468880"/>
+            <a:ext cx="3657600" cy="365760"/>
+          </a:xfrm>
+          <a:prstGeom prst="rect">
+            <a:avLst/>
+          </a:prstGeom>
+          <a:noFill/>
+        </p:spPr>
+        <p:txBody>
+          <a:bodyPr wrap="square">
+            <a:spAutoFit/>
+          </a:bodyPr>
+          <a:lstStyle/>
+          <a:p>
+            <a:pPr algn="l">
+              <a:defRPr sz="1600" b="1">
+                <a:solidFill>
+                  <a:srgbClr val="0078D4"/>
+                </a:solidFill>
+                <a:latin typeface="Segoe UI"/>
+              </a:defRPr>
+            </a:pPr>
+            <a:r>
+              <a:t>Foundry Dev Blog</a:t>
+            </a:r>
+          </a:p>
+        </p:txBody>
+      </p:sp>
+      <p:sp>
+        <p:nvSpPr>
+          <p:cNvPr id="10" name="TextBox 9"/>
+          <p:cNvSpPr txBox="1"/>
+          <p:nvPr/>
+        </p:nvSpPr>
+        <p:spPr>
+          <a:xfrm>
+            <a:off x="4754880" y="2468880"/>
+            <a:ext cx="6858000" cy="365760"/>
+          </a:xfrm>
+          <a:prstGeom prst="rect">
+            <a:avLst/>
+          </a:prstGeom>
+          <a:noFill/>
+        </p:spPr>
+        <p:txBody>
+          <a:bodyPr wrap="square">
+            <a:spAutoFit/>
+          </a:bodyPr>
+          <a:lstStyle/>
+          <a:p>
+            <a:pPr algn="l">
+              <a:defRPr sz="1400" b="0">
+                <a:solidFill>
+                  <a:srgbClr val="CCCCCC"/>
+                </a:solidFill>
+                <a:latin typeface="Segoe UI"/>
+              </a:defRPr>
+            </a:pPr>
+            <a:r>
+              <a:t>https://devblogs.microsoft.com/foundry/</a:t>
+            </a:r>
+          </a:p>
+        </p:txBody>
+      </p:sp>
+      <p:sp>
+        <p:nvSpPr>
+          <p:cNvPr id="11" name="TextBox 10"/>
+          <p:cNvSpPr txBox="1"/>
+          <p:nvPr/>
+        </p:nvSpPr>
+        <p:spPr>
+          <a:xfrm>
+            <a:off x="914400" y="2971800"/>
+            <a:ext cx="3657600" cy="365760"/>
+          </a:xfrm>
+          <a:prstGeom prst="rect">
+            <a:avLst/>
+          </a:prstGeom>
+          <a:noFill/>
+        </p:spPr>
+        <p:txBody>
+          <a:bodyPr wrap="square">
+            <a:spAutoFit/>
+          </a:bodyPr>
+          <a:lstStyle/>
+          <a:p>
+            <a:pPr algn="l">
+              <a:defRPr sz="1600" b="1">
+                <a:solidFill>
+                  <a:srgbClr val="0078D4"/>
+                </a:solidFill>
+                <a:latin typeface="Segoe UI"/>
+              </a:defRPr>
+            </a:pPr>
+            <a:r>
+              <a:t>Azure OpenAI What’s New</a:t>
+            </a:r>
+          </a:p>
+        </p:txBody>
+      </p:sp>
+      <p:sp>
+        <p:nvSpPr>
+          <p:cNvPr id="12" name="TextBox 11"/>
+          <p:cNvSpPr txBox="1"/>
+          <p:nvPr/>
+        </p:nvSpPr>
+        <p:spPr>
+          <a:xfrm>
+            <a:off x="4754880" y="2971800"/>
+            <a:ext cx="6858000" cy="365760"/>
+          </a:xfrm>
+          <a:prstGeom prst="rect">
+            <a:avLst/>
+          </a:prstGeom>
+          <a:noFill/>
+        </p:spPr>
+        <p:txBody>
+          <a:bodyPr wrap="square">
+            <a:spAutoFit/>
+          </a:bodyPr>
+          <a:lstStyle/>
+          <a:p>
+            <a:pPr algn="l">
+              <a:defRPr sz="1400" b="0">
+                <a:solidFill>
+                  <a:srgbClr val="CCCCCC"/>
+                </a:solidFill>
+                <a:latin typeface="Segoe UI"/>
+              </a:defRPr>
+            </a:pPr>
+            <a:r>
+              <a:t>https://learn.microsoft.com/en-us/azure/ai-foundry/openai/whats-new</a:t>
+            </a:r>
+          </a:p>
+        </p:txBody>
+      </p:sp>
+      <p:sp>
+        <p:nvSpPr>
+          <p:cNvPr id="13" name="TextBox 12"/>
+          <p:cNvSpPr txBox="1"/>
+          <p:nvPr/>
+        </p:nvSpPr>
+        <p:spPr>
+          <a:xfrm>
+            <a:off x="914400" y="3474720"/>
+            <a:ext cx="3657600" cy="365760"/>
+          </a:xfrm>
+          <a:prstGeom prst="rect">
+            <a:avLst/>
+          </a:prstGeom>
+          <a:noFill/>
+        </p:spPr>
+        <p:txBody>
+          <a:bodyPr wrap="square">
+            <a:spAutoFit/>
+          </a:bodyPr>
+          <a:lstStyle/>
+          <a:p>
+            <a:pPr algn="l">
+              <a:defRPr sz="1600" b="1">
+                <a:solidFill>
+                  <a:srgbClr val="0078D4"/>
+                </a:solidFill>
+                <a:latin typeface="Segoe UI"/>
+              </a:defRPr>
+            </a:pPr>
+            <a:r>
+              <a:t>Model Retirements</a:t>
+            </a:r>
+          </a:p>
+        </p:txBody>
+      </p:sp>
+      <p:sp>
+        <p:nvSpPr>
+          <p:cNvPr id="14" name="TextBox 13"/>
+          <p:cNvSpPr txBox="1"/>
+          <p:nvPr/>
+        </p:nvSpPr>
+        <p:spPr>
+          <a:xfrm>
+            <a:off x="4754880" y="3474720"/>
+            <a:ext cx="6858000" cy="365760"/>
+          </a:xfrm>
+          <a:prstGeom prst="rect">
+            <a:avLst/>
+          </a:prstGeom>
+          <a:noFill/>
+        </p:spPr>
+        <p:txBody>
+          <a:bodyPr wrap="square">
+            <a:spAutoFit/>
+          </a:bodyPr>
+          <a:lstStyle/>
+          <a:p>
+            <a:pPr algn="l">
+              <a:defRPr sz="1400" b="0">
+                <a:solidFill>
+                  <a:srgbClr val="CCCCCC"/>
+                </a:solidFill>
+                <a:latin typeface="Segoe UI"/>
+              </a:defRPr>
+            </a:pPr>
+            <a:r>
+              <a:t>https://learn.microsoft.com/en-us/azure/ai-foundry/openai/concepts/model-retirements</a:t>
+            </a:r>
+          </a:p>
+        </p:txBody>
+      </p:sp>
+      <p:sp>
+        <p:nvSpPr>
+          <p:cNvPr id="15" name="TextBox 14"/>
+          <p:cNvSpPr txBox="1"/>
+          <p:nvPr/>
+        </p:nvSpPr>
+        <p:spPr>
+          <a:xfrm>
+            <a:off x="914400" y="3977640"/>
+            <a:ext cx="3657600" cy="365760"/>
+          </a:xfrm>
+          <a:prstGeom prst="rect">
+            <a:avLst/>
+          </a:prstGeom>
+          <a:noFill/>
+        </p:spPr>
+        <p:txBody>
+          <a:bodyPr wrap="square">
+            <a:spAutoFit/>
+          </a:bodyPr>
+          <a:lstStyle/>
+          <a:p>
+            <a:pPr algn="l">
+              <a:defRPr sz="1600" b="1">
+                <a:solidFill>
+                  <a:srgbClr val="0078D4"/>
+                </a:solidFill>
+                <a:latin typeface="Segoe UI"/>
+              </a:defRPr>
+            </a:pPr>
+            <a:r>
+              <a:t>Azure AI Blog</a:t>
+            </a:r>
+          </a:p>
+        </p:txBody>
+      </p:sp>
+      <p:sp>
+        <p:nvSpPr>
+          <p:cNvPr id="16" name="TextBox 15"/>
+          <p:cNvSpPr txBox="1"/>
+          <p:nvPr/>
+        </p:nvSpPr>
+        <p:spPr>
+          <a:xfrm>
+            <a:off x="4754880" y="3977640"/>
+            <a:ext cx="6858000" cy="365760"/>
+          </a:xfrm>
+          <a:prstGeom prst="rect">
+            <a:avLst/>
+          </a:prstGeom>
+          <a:noFill/>
+        </p:spPr>
+        <p:txBody>
+          <a:bodyPr wrap="square">
+            <a:spAutoFit/>
+          </a:bodyPr>
+          <a:lstStyle/>
+          <a:p>
+            <a:pPr algn="l">
+              <a:defRPr sz="1400" b="0">
+                <a:solidFill>
+                  <a:srgbClr val="CCCCCC"/>
+                </a:solidFill>
+                <a:latin typeface="Segoe UI"/>
+              </a:defRPr>
+            </a:pPr>
+            <a:r>
+              <a:t>https://azure.microsoft.com/en-us/blog/category/ai-machine-learning/</a:t>
+            </a:r>
+          </a:p>
+        </p:txBody>
+      </p:sp>
+      <p:sp>
+        <p:nvSpPr>
+          <p:cNvPr id="17" name="TextBox 16"/>
+          <p:cNvSpPr txBox="1"/>
+          <p:nvPr/>
+        </p:nvSpPr>
+        <p:spPr>
+          <a:xfrm>
+            <a:off x="914400" y="4480560"/>
+            <a:ext cx="3657600" cy="365760"/>
+          </a:xfrm>
+          <a:prstGeom prst="rect">
+            <a:avLst/>
+          </a:prstGeom>
+          <a:noFill/>
+        </p:spPr>
+        <p:txBody>
+          <a:bodyPr wrap="square">
+            <a:spAutoFit/>
+          </a:bodyPr>
+          <a:lstStyle/>
+          <a:p>
+            <a:pPr algn="l">
+              <a:defRPr sz="1600" b="1">
+                <a:solidFill>
+                  <a:srgbClr val="0078D4"/>
+                </a:solidFill>
+                <a:latin typeface="Segoe UI"/>
+              </a:defRPr>
+            </a:pPr>
+            <a:r>
+              <a:t>Foundry Tech Community</a:t>
+            </a:r>
+          </a:p>
+        </p:txBody>
+      </p:sp>
+      <p:sp>
+        <p:nvSpPr>
+          <p:cNvPr id="18" name="TextBox 17"/>
+          <p:cNvSpPr txBox="1"/>
+          <p:nvPr/>
+        </p:nvSpPr>
+        <p:spPr>
+          <a:xfrm>
+            <a:off x="4754880" y="4480560"/>
+            <a:ext cx="6858000" cy="365760"/>
+          </a:xfrm>
+          <a:prstGeom prst="rect">
+            <a:avLst/>
+          </a:prstGeom>
+          <a:noFill/>
+        </p:spPr>
+        <p:txBody>
+          <a:bodyPr wrap="square">
+            <a:spAutoFit/>
+          </a:bodyPr>
+          <a:lstStyle/>
+          <a:p>
+            <a:pPr algn="l">
+              <a:defRPr sz="1400" b="0">
+                <a:solidFill>
+                  <a:srgbClr val="CCCCCC"/>
+                </a:solidFill>
+                <a:latin typeface="Segoe UI"/>
+              </a:defRPr>
+            </a:pPr>
+            <a:r>
+              <a:t>https://techcommunity.microsoft.com/category/azure-ai-foundry/blog/azure-ai-foundry-blog/</a:t>
+            </a:r>
+          </a:p>
+        </p:txBody>
+      </p:sp>
+      <p:sp>
+        <p:nvSpPr>
+          <p:cNvPr id="19" name="TextBox 18"/>
+          <p:cNvSpPr txBox="1"/>
+          <p:nvPr/>
+        </p:nvSpPr>
+        <p:spPr>
+          <a:xfrm>
+            <a:off x="914400" y="4983480"/>
+            <a:ext cx="3657600" cy="365760"/>
+          </a:xfrm>
+          <a:prstGeom prst="rect">
+            <a:avLst/>
+          </a:prstGeom>
+          <a:noFill/>
+        </p:spPr>
+        <p:txBody>
+          <a:bodyPr wrap="square">
+            <a:spAutoFit/>
+          </a:bodyPr>
+          <a:lstStyle/>
+          <a:p>
+            <a:pPr algn="l">
+              <a:defRPr sz="1600" b="1">
+                <a:solidFill>
+                  <a:srgbClr val="0078D4"/>
+                </a:solidFill>
+                <a:latin typeface="Segoe UI"/>
+              </a:defRPr>
+            </a:pPr>
+            <a:r>
+              <a:t>Foundry Models Catalog</a:t>
+            </a:r>
+          </a:p>
+        </p:txBody>
+      </p:sp>
+      <p:sp>
+        <p:nvSpPr>
+          <p:cNvPr id="20" name="TextBox 19"/>
+          <p:cNvSpPr txBox="1"/>
+          <p:nvPr/>
+        </p:nvSpPr>
+        <p:spPr>
+          <a:xfrm>
+            <a:off x="4754880" y="4983480"/>
+            <a:ext cx="6858000" cy="365760"/>
+          </a:xfrm>
+          <a:prstGeom prst="rect">
+            <a:avLst/>
+          </a:prstGeom>
+          <a:noFill/>
+        </p:spPr>
+        <p:txBody>
+          <a:bodyPr wrap="square">
+            <a:spAutoFit/>
+          </a:bodyPr>
+          <a:lstStyle/>
+          <a:p>
+            <a:pPr algn="l">
+              <a:defRPr sz="1400" b="0">
+                <a:solidFill>
+                  <a:srgbClr val="CCCCCC"/>
+                </a:solidFill>
+                <a:latin typeface="Segoe UI"/>
+              </a:defRPr>
+            </a:pPr>
+            <a:r>
+              <a:t>https://azure.microsoft.com/en-us/products/ai-foundry/models/</a:t>
+            </a:r>
+          </a:p>
+        </p:txBody>
+      </p:sp>
+      <p:sp>
+        <p:nvSpPr>
+          <p:cNvPr id="21" name="TextBox 20"/>
+          <p:cNvSpPr txBox="1"/>
+          <p:nvPr/>
+        </p:nvSpPr>
+        <p:spPr>
+          <a:xfrm>
+            <a:off x="914400" y="5486400"/>
+            <a:ext cx="3657600" cy="365760"/>
+          </a:xfrm>
+          <a:prstGeom prst="rect">
+            <a:avLst/>
+          </a:prstGeom>
+          <a:noFill/>
+        </p:spPr>
+        <p:txBody>
+          <a:bodyPr wrap="square">
+            <a:spAutoFit/>
+          </a:bodyPr>
+          <a:lstStyle/>
+          <a:p>
+            <a:pPr algn="l">
+              <a:defRPr sz="1600" b="1">
+                <a:solidFill>
+                  <a:srgbClr val="0078D4"/>
+                </a:solidFill>
+                <a:latin typeface="Segoe UI"/>
+              </a:defRPr>
+            </a:pPr>
+            <a:r>
+              <a:t>Foundry Agent Service</a:t>
+            </a:r>
+          </a:p>
+        </p:txBody>
+      </p:sp>
+      <p:sp>
+        <p:nvSpPr>
+          <p:cNvPr id="22" name="TextBox 21"/>
+          <p:cNvSpPr txBox="1"/>
+          <p:nvPr/>
+        </p:nvSpPr>
+        <p:spPr>
+          <a:xfrm>
+            <a:off x="4754880" y="5486400"/>
+            <a:ext cx="6858000" cy="365760"/>
+          </a:xfrm>
+          <a:prstGeom prst="rect">
+            <a:avLst/>
+          </a:prstGeom>
+          <a:noFill/>
+        </p:spPr>
+        <p:txBody>
+          <a:bodyPr wrap="square">
+            <a:spAutoFit/>
+          </a:bodyPr>
+          <a:lstStyle/>
+          <a:p>
+            <a:pPr algn="l">
+              <a:defRPr sz="1400" b="0">
+                <a:solidFill>
+                  <a:srgbClr val="CCCCCC"/>
+                </a:solidFill>
+                <a:latin typeface="Segoe UI"/>
+              </a:defRPr>
+            </a:pPr>
+            <a:r>
+              <a:t>https://azure.microsoft.com/en-us/products/ai-foundry/agent-service/</a:t>
+            </a:r>
+          </a:p>
+        </p:txBody>
+      </p:sp>
+      <p:sp>
+        <p:nvSpPr>
+          <p:cNvPr id="23" name="TextBox 22"/>
+          <p:cNvSpPr txBox="1"/>
+          <p:nvPr/>
+        </p:nvSpPr>
+        <p:spPr>
+          <a:xfrm>
+            <a:off x="914400" y="5989320"/>
+            <a:ext cx="3657600" cy="365760"/>
+          </a:xfrm>
+          <a:prstGeom prst="rect">
+            <a:avLst/>
+          </a:prstGeom>
+          <a:noFill/>
+        </p:spPr>
+        <p:txBody>
+          <a:bodyPr wrap="square">
+            <a:spAutoFit/>
+          </a:bodyPr>
+          <a:lstStyle/>
+          <a:p>
+            <a:pPr algn="l">
+              <a:defRPr sz="1600" b="1">
+                <a:solidFill>
+                  <a:srgbClr val="0078D4"/>
+                </a:solidFill>
+                <a:latin typeface="Segoe UI"/>
+              </a:defRPr>
+            </a:pPr>
+            <a:r>
+              <a:t>Azure Updates Feed</a:t>
+            </a:r>
+          </a:p>
+        </p:txBody>
+      </p:sp>
+      <p:sp>
+        <p:nvSpPr>
+          <p:cNvPr id="24" name="TextBox 23"/>
+          <p:cNvSpPr txBox="1"/>
+          <p:nvPr/>
+        </p:nvSpPr>
+        <p:spPr>
+          <a:xfrm>
+            <a:off x="4754880" y="5989320"/>
+            <a:ext cx="6858000" cy="365760"/>
+          </a:xfrm>
+          <a:prstGeom prst="rect">
+            <a:avLst/>
+          </a:prstGeom>
+          <a:noFill/>
+        </p:spPr>
+        <p:txBody>
+          <a:bodyPr wrap="square">
+            <a:spAutoFit/>
+          </a:bodyPr>
+          <a:lstStyle/>
+          <a:p>
+            <a:pPr algn="l">
+              <a:defRPr sz="1400" b="0">
+                <a:solidFill>
+                  <a:srgbClr val="CCCCCC"/>
+                </a:solidFill>
+                <a:latin typeface="Segoe UI"/>
+              </a:defRPr>
+            </a:pPr>
+            <a:r>
+              <a:t>https://azure.microsoft.com/en-us/updates/</a:t>
+            </a:r>
+          </a:p>
+        </p:txBody>
+      </p:sp>
+    </p:spTree>
+  </p:cSld>
+  <p:clrMapOvr>
+    <a:masterClrMapping/>
+  </p:clrMapOvr>
+</p:sld>
+</file>
+
+<file path=ppt/slides/slide12.xml><?xml version="1.0" encoding="utf-8"?>
+<p:sld xmlns:a="http://schemas.openxmlformats.org/drawingml/2006/main" xmlns:p="http://schemas.openxmlformats.org/presentationml/2006/main" xmlns:r="http://schemas.openxmlformats.org/officeDocument/2006/relationships">
+  <p:cSld>
+    <p:bg>
+      <p:bgPr>
+        <a:solidFill>
+          <a:srgbClr val="1B1B1B"/>
+        </a:solidFill>
+        <a:effectLst/>
+      </p:bgPr>
+    </p:bg>
+    <p:spTree>
+      <p:nvGrpSpPr>
+        <p:cNvPr id="1" name=""/>
+        <p:cNvGrpSpPr/>
+        <p:nvPr/>
+      </p:nvGrpSpPr>
+      <p:grpSpPr/>
+      <p:sp>
+        <p:nvSpPr>
+          <p:cNvPr id="2" name="Rectangle 1"/>
+          <p:cNvSpPr/>
+          <p:nvPr/>
+        </p:nvSpPr>
+        <p:spPr>
+          <a:xfrm>
+            <a:off x="0" y="0"/>
+            <a:ext cx="12191695" cy="137160"/>
+          </a:xfrm>
+          <a:prstGeom prst="rect">
+            <a:avLst/>
+          </a:prstGeom>
+          <a:solidFill>
+            <a:srgbClr val="0078D4"/>
+          </a:solidFill>
+          <a:ln>
+            <a:noFill/>
+          </a:ln>
+        </p:spPr>
+        <p:style>
+          <a:lnRef idx="1">
+            <a:schemeClr val="accent1"/>
+          </a:lnRef>
+          <a:fillRef idx="3">
+            <a:schemeClr val="accent1"/>
+          </a:fillRef>
+          <a:effectRef idx="2">
+            <a:schemeClr val="accent1"/>
+          </a:effectRef>
+          <a:fontRef idx="minor">
+            <a:schemeClr val="lt1"/>
+          </a:fontRef>
+        </p:style>
+        <p:txBody>
+          <a:bodyPr rtlCol="0" anchor="ctr"/>
+          <a:lstStyle/>
+          <a:p>
+            <a:pPr algn="ctr"/>
+          </a:p>
+        </p:txBody>
+      </p:sp>
+      <p:sp>
+        <p:nvSpPr>
+          <p:cNvPr id="3" name="TextBox 2"/>
+          <p:cNvSpPr txBox="1"/>
+          <p:nvPr/>
+        </p:nvSpPr>
+        <p:spPr>
+          <a:xfrm>
             <a:off x="731520" y="2286000"/>
             <a:ext cx="10515600" cy="1097280"/>
           </a:xfrm>
@@ -4769,7 +6146,7 @@
               </a:defRPr>
             </a:pPr>
             <a:r>
-              <a:t>Model Deprecations &amp; Retirements</a:t>
+              <a:t>Foundry Blog Highlights</a:t>
             </a:r>
           </a:p>
         </p:txBody>
@@ -4819,6 +6196,78 @@
         <p:spPr>
           <a:xfrm>
             <a:off x="1463040" y="4617720"/>
+            <a:ext cx="9144000" cy="457200"/>
+          </a:xfrm>
+          <a:prstGeom prst="rect">
+            <a:avLst/>
+          </a:prstGeom>
+          <a:noFill/>
+        </p:spPr>
+        <p:txBody>
+          <a:bodyPr wrap="square">
+            <a:spAutoFit/>
+          </a:bodyPr>
+          <a:lstStyle/>
+          <a:p>
+            <a:pPr algn="l">
+              <a:defRPr sz="2000" b="0">
+                <a:solidFill>
+                  <a:srgbClr val="FFFFFF"/>
+                </a:solidFill>
+                <a:latin typeface="Segoe UI"/>
+              </a:defRPr>
+            </a:pPr>
+            <a:r>
+              <a:t>Model Deprecations &amp; Retirements</a:t>
+            </a:r>
+          </a:p>
+        </p:txBody>
+      </p:sp>
+      <p:sp>
+        <p:nvSpPr>
+          <p:cNvPr id="17" name="TextBox 16"/>
+          <p:cNvSpPr txBox="1"/>
+          <p:nvPr/>
+        </p:nvSpPr>
+        <p:spPr>
+          <a:xfrm>
+            <a:off x="914400" y="5212080"/>
+            <a:ext cx="457200" cy="457200"/>
+          </a:xfrm>
+          <a:prstGeom prst="rect">
+            <a:avLst/>
+          </a:prstGeom>
+          <a:noFill/>
+        </p:spPr>
+        <p:txBody>
+          <a:bodyPr wrap="square">
+            <a:spAutoFit/>
+          </a:bodyPr>
+          <a:lstStyle/>
+          <a:p>
+            <a:pPr algn="l">
+              <a:defRPr sz="2000" b="1">
+                <a:solidFill>
+                  <a:srgbClr val="0078D4"/>
+                </a:solidFill>
+                <a:latin typeface="Segoe UI"/>
+              </a:defRPr>
+            </a:pPr>
+            <a:r>
+              <a:t>7.</a:t>
+            </a:r>
+          </a:p>
+        </p:txBody>
+      </p:sp>
+      <p:sp>
+        <p:nvSpPr>
+          <p:cNvPr id="18" name="TextBox 17"/>
+          <p:cNvSpPr txBox="1"/>
+          <p:nvPr/>
+        </p:nvSpPr>
+        <p:spPr>
+          <a:xfrm>
+            <a:off x="1463040" y="5212080"/>
             <a:ext cx="9144000" cy="457200"/>
           </a:xfrm>
           <a:prstGeom prst="rect">
@@ -5807,6 +7256,293 @@
 </file>
 
 <file path=ppt/slides/slide7.xml><?xml version="1.0" encoding="utf-8"?>
+<p:sld xmlns:a="http://schemas.openxmlformats.org/drawingml/2006/main" xmlns:p="http://schemas.openxmlformats.org/presentationml/2006/main" xmlns:r="http://schemas.openxmlformats.org/officeDocument/2006/relationships">
+  <p:cSld>
+    <p:bg>
+      <p:bgPr>
+        <a:solidFill>
+          <a:srgbClr val="1B1B1B"/>
+        </a:solidFill>
+        <a:effectLst/>
+      </p:bgPr>
+    </p:bg>
+    <p:spTree>
+      <p:nvGrpSpPr>
+        <p:cNvPr id="1" name=""/>
+        <p:cNvGrpSpPr/>
+        <p:nvPr/>
+      </p:nvGrpSpPr>
+      <p:grpSpPr/>
+      <p:sp>
+        <p:nvSpPr>
+          <p:cNvPr id="2" name="Rectangle 1"/>
+          <p:cNvSpPr/>
+          <p:nvPr/>
+        </p:nvSpPr>
+        <p:spPr>
+          <a:xfrm>
+            <a:off x="0" y="0"/>
+            <a:ext cx="12191695" cy="137160"/>
+          </a:xfrm>
+          <a:prstGeom prst="rect">
+            <a:avLst/>
+          </a:prstGeom>
+          <a:solidFill>
+            <a:srgbClr val="0078D4"/>
+          </a:solidFill>
+          <a:ln>
+            <a:noFill/>
+          </a:ln>
+        </p:spPr>
+        <p:style>
+          <a:lnRef idx="1">
+            <a:schemeClr val="accent1"/>
+          </a:lnRef>
+          <a:fillRef idx="3">
+            <a:schemeClr val="accent1"/>
+          </a:fillRef>
+          <a:effectRef idx="2">
+            <a:schemeClr val="accent1"/>
+          </a:effectRef>
+          <a:fontRef idx="minor">
+            <a:schemeClr val="lt1"/>
+          </a:fontRef>
+        </p:style>
+        <p:txBody>
+          <a:bodyPr rtlCol="0" anchor="ctr"/>
+          <a:lstStyle/>
+          <a:p>
+            <a:pPr algn="ctr"/>
+          </a:p>
+        </p:txBody>
+      </p:sp>
+      <p:sp>
+        <p:nvSpPr>
+          <p:cNvPr id="3" name="TextBox 2"/>
+          <p:cNvSpPr txBox="1"/>
+          <p:nvPr/>
+        </p:nvSpPr>
+        <p:spPr>
+          <a:xfrm>
+            <a:off x="731520" y="365760"/>
+            <a:ext cx="10058400" cy="640080"/>
+          </a:xfrm>
+          <a:prstGeom prst="rect">
+            <a:avLst/>
+          </a:prstGeom>
+          <a:noFill/>
+        </p:spPr>
+        <p:txBody>
+          <a:bodyPr wrap="square">
+            <a:spAutoFit/>
+          </a:bodyPr>
+          <a:lstStyle/>
+          <a:p>
+            <a:pPr algn="l">
+              <a:defRPr sz="3400" b="1">
+                <a:solidFill>
+                  <a:srgbClr val="FFFFFF"/>
+                </a:solidFill>
+                <a:latin typeface="Segoe UI"/>
+              </a:defRPr>
+            </a:pPr>
+            <a:r>
+              <a:t>Foundry Blog Highlights (Feb 2026)</a:t>
+            </a:r>
+          </a:p>
+        </p:txBody>
+      </p:sp>
+      <p:sp>
+        <p:nvSpPr>
+          <p:cNvPr id="4" name="Rectangle 3"/>
+          <p:cNvSpPr/>
+          <p:nvPr/>
+        </p:nvSpPr>
+        <p:spPr>
+          <a:xfrm>
+            <a:off x="457200" y="1005840"/>
+            <a:ext cx="1097280" cy="50800"/>
+          </a:xfrm>
+          <a:prstGeom prst="rect">
+            <a:avLst/>
+          </a:prstGeom>
+          <a:solidFill>
+            <a:srgbClr val="0078D4"/>
+          </a:solidFill>
+          <a:ln>
+            <a:noFill/>
+          </a:ln>
+        </p:spPr>
+        <p:style>
+          <a:lnRef idx="1">
+            <a:schemeClr val="accent1"/>
+          </a:lnRef>
+          <a:fillRef idx="3">
+            <a:schemeClr val="accent1"/>
+          </a:fillRef>
+          <a:effectRef idx="2">
+            <a:schemeClr val="accent1"/>
+          </a:effectRef>
+          <a:fontRef idx="minor">
+            <a:schemeClr val="lt1"/>
+          </a:fontRef>
+        </p:style>
+        <p:txBody>
+          <a:bodyPr rtlCol="0" anchor="ctr"/>
+          <a:lstStyle/>
+          <a:p>
+            <a:pPr algn="ctr"/>
+          </a:p>
+        </p:txBody>
+      </p:sp>
+      <p:sp>
+        <p:nvSpPr>
+          <p:cNvPr id="5" name="TextBox 4"/>
+          <p:cNvSpPr txBox="1"/>
+          <p:nvPr/>
+        </p:nvSpPr>
+        <p:spPr>
+          <a:xfrm>
+            <a:off x="731520" y="1371600"/>
+            <a:ext cx="10515600" cy="4572000"/>
+          </a:xfrm>
+          <a:prstGeom prst="rect">
+            <a:avLst/>
+          </a:prstGeom>
+          <a:noFill/>
+        </p:spPr>
+        <p:txBody>
+          <a:bodyPr wrap="square">
+            <a:spAutoFit/>
+          </a:bodyPr>
+          <a:lstStyle/>
+          <a:p>
+            <a:pPr>
+              <a:spcBef>
+                <a:spcPts val="800"/>
+              </a:spcBef>
+              <a:spcAft>
+                <a:spcPts val="400"/>
+              </a:spcAft>
+            </a:pPr>
+            <a:r>
+              <a:rPr sz="1600" b="1">
+                <a:solidFill>
+                  <a:srgbClr val="0078D4"/>
+                </a:solidFill>
+                <a:latin typeface="Segoe UI"/>
+              </a:rPr>
+              <a:t>Microsoft Agent Framework – Release Candidate (Feb 19)</a:t>
+            </a:r>
+            <a:r>
+              <a:rPr sz="1400" b="0">
+                <a:solidFill>
+                  <a:srgbClr val="FFFFFF"/>
+                </a:solidFill>
+                <a:latin typeface="Segoe UI"/>
+              </a:rPr>
+              <a:t>
+Successor to Semantic Kernel &amp; AutoGen. Stable API for v1.0 in .NET &amp; Python. Graph-based workflows, multi-provider support (Foundry, OpenAI, Claude, Bedrock, Ollama), A2A / AG-UI / MCP interoperability.</a:t>
+            </a:r>
+          </a:p>
+          <a:p>
+            <a:pPr>
+              <a:spcBef>
+                <a:spcPts val="800"/>
+              </a:spcBef>
+              <a:spcAft>
+                <a:spcPts val="400"/>
+              </a:spcAft>
+            </a:pPr>
+            <a:r>
+              <a:rPr sz="1600" b="1">
+                <a:solidFill>
+                  <a:srgbClr val="0078D4"/>
+                </a:solidFill>
+                <a:latin typeface="Segoe UI"/>
+              </a:rPr>
+              <a:t>What’s New in Foundry | Dec 2025 &amp; Jan 2026 (Feb 18)</a:t>
+            </a:r>
+            <a:r>
+              <a:rPr sz="1400" b="0">
+                <a:solidFill>
+                  <a:srgbClr val="FFFFFF"/>
+                </a:solidFill>
+                <a:latin typeface="Segoe UI"/>
+              </a:rPr>
+              <a:t>
+Comprehensive roundup: GPT-5.2 GA, Codex Max GA, Mistral Large 3, DeepSeek V3.2, Kimi-K2 Thinking, Cohere Rerank 4, GPT-image-1.5 GA, FLUX.2 [pro], Memory in Agent Service, A2A Tool, Computer Use, Foundry MCP Server, azure-ai-projects v2 beta.</a:t>
+            </a:r>
+          </a:p>
+          <a:p>
+            <a:pPr>
+              <a:spcBef>
+                <a:spcPts val="800"/>
+              </a:spcBef>
+              <a:spcAft>
+                <a:spcPts val="400"/>
+              </a:spcAft>
+            </a:pPr>
+            <a:r>
+              <a:rPr sz="1600" b="1">
+                <a:solidFill>
+                  <a:srgbClr val="0078D4"/>
+                </a:solidFill>
+                <a:latin typeface="Segoe UI"/>
+              </a:rPr>
+              <a:t>DPO Fine-Tuning Using Foundry SDK (Feb 13)</a:t>
+            </a:r>
+            <a:r>
+              <a:rPr sz="1400" b="0">
+                <a:solidFill>
+                  <a:srgbClr val="FFFFFF"/>
+                </a:solidFill>
+                <a:latin typeface="Segoe UI"/>
+              </a:rPr>
+              <a:t>
+Guide to Direct Preference Optimization – learn from human preference pairs to align model behaviour without a separate reward model.</a:t>
+            </a:r>
+          </a:p>
+          <a:p>
+            <a:pPr>
+              <a:spcBef>
+                <a:spcPts val="800"/>
+              </a:spcBef>
+              <a:spcAft>
+                <a:spcPts val="400"/>
+              </a:spcAft>
+            </a:pPr>
+            <a:r>
+              <a:rPr sz="1600" b="1">
+                <a:solidFill>
+                  <a:srgbClr val="0078D4"/>
+                </a:solidFill>
+                <a:latin typeface="Segoe UI"/>
+              </a:rPr>
+              <a:t>Beyond the Prompt – Why &amp; How to Fine-tune (Feb 6)</a:t>
+            </a:r>
+            <a:r>
+              <a:rPr sz="1400" b="0">
+                <a:solidFill>
+                  <a:srgbClr val="FFFFFF"/>
+                </a:solidFill>
+                <a:latin typeface="Segoe UI"/>
+              </a:rPr>
+              <a:t>
+When prompt engineering &amp; RAG aren’t enough: fine-tuning for consistent, policy-compliant outputs at enterprise scale.</a:t>
+            </a:r>
+          </a:p>
+        </p:txBody>
+      </p:sp>
+    </p:spTree>
+  </p:cSld>
+  <p:clrMapOvr>
+    <a:masterClrMapping/>
+  </p:clrMapOvr>
+</p:sld>
+</file>
+
+<file path=ppt/slides/slide8.xml><?xml version="1.0" encoding="utf-8"?>
 <p:sld xmlns:a="http://schemas.openxmlformats.org/drawingml/2006/main" xmlns:p="http://schemas.openxmlformats.org/presentationml/2006/main" xmlns:r="http://schemas.openxmlformats.org/officeDocument/2006/relationships">
   <p:cSld>
     <p:bg>
@@ -6676,322 +8412,6 @@
 </p:sld>
 </file>
 
-<file path=ppt/slides/slide8.xml><?xml version="1.0" encoding="utf-8"?>
-<p:sld xmlns:a="http://schemas.openxmlformats.org/drawingml/2006/main" xmlns:p="http://schemas.openxmlformats.org/presentationml/2006/main" xmlns:r="http://schemas.openxmlformats.org/officeDocument/2006/relationships">
-  <p:cSld>
-    <p:bg>
-      <p:bgPr>
-        <a:solidFill>
-          <a:srgbClr val="1B1B1B"/>
-        </a:solidFill>
-        <a:effectLst/>
-      </p:bgPr>
-    </p:bg>
-    <p:spTree>
-      <p:nvGrpSpPr>
-        <p:cNvPr id="1" name=""/>
-        <p:cNvGrpSpPr/>
-        <p:nvPr/>
-      </p:nvGrpSpPr>
-      <p:grpSpPr/>
-      <p:sp>
-        <p:nvSpPr>
-          <p:cNvPr id="2" name="Rectangle 1"/>
-          <p:cNvSpPr/>
-          <p:nvPr/>
-        </p:nvSpPr>
-        <p:spPr>
-          <a:xfrm>
-            <a:off x="0" y="0"/>
-            <a:ext cx="12191695" cy="137160"/>
-          </a:xfrm>
-          <a:prstGeom prst="rect">
-            <a:avLst/>
-          </a:prstGeom>
-          <a:solidFill>
-            <a:srgbClr val="0078D4"/>
-          </a:solidFill>
-          <a:ln>
-            <a:noFill/>
-          </a:ln>
-        </p:spPr>
-        <p:style>
-          <a:lnRef idx="1">
-            <a:schemeClr val="accent1"/>
-          </a:lnRef>
-          <a:fillRef idx="3">
-            <a:schemeClr val="accent1"/>
-          </a:fillRef>
-          <a:effectRef idx="2">
-            <a:schemeClr val="accent1"/>
-          </a:effectRef>
-          <a:fontRef idx="minor">
-            <a:schemeClr val="lt1"/>
-          </a:fontRef>
-        </p:style>
-        <p:txBody>
-          <a:bodyPr rtlCol="0" anchor="ctr"/>
-          <a:lstStyle/>
-          <a:p>
-            <a:pPr algn="ctr"/>
-          </a:p>
-        </p:txBody>
-      </p:sp>
-      <p:sp>
-        <p:nvSpPr>
-          <p:cNvPr id="3" name="TextBox 2"/>
-          <p:cNvSpPr txBox="1"/>
-          <p:nvPr/>
-        </p:nvSpPr>
-        <p:spPr>
-          <a:xfrm>
-            <a:off x="731520" y="365760"/>
-            <a:ext cx="10058400" cy="640080"/>
-          </a:xfrm>
-          <a:prstGeom prst="rect">
-            <a:avLst/>
-          </a:prstGeom>
-          <a:noFill/>
-        </p:spPr>
-        <p:txBody>
-          <a:bodyPr wrap="square">
-            <a:spAutoFit/>
-          </a:bodyPr>
-          <a:lstStyle/>
-          <a:p>
-            <a:pPr algn="l">
-              <a:defRPr sz="3400" b="1">
-                <a:solidFill>
-                  <a:srgbClr val="FFFFFF"/>
-                </a:solidFill>
-                <a:latin typeface="Segoe UI"/>
-              </a:defRPr>
-            </a:pPr>
-            <a:r>
-              <a:t>Retirement Action Items</a:t>
-            </a:r>
-          </a:p>
-        </p:txBody>
-      </p:sp>
-      <p:sp>
-        <p:nvSpPr>
-          <p:cNvPr id="4" name="Rectangle 3"/>
-          <p:cNvSpPr/>
-          <p:nvPr/>
-        </p:nvSpPr>
-        <p:spPr>
-          <a:xfrm>
-            <a:off x="457200" y="1005840"/>
-            <a:ext cx="1097280" cy="50800"/>
-          </a:xfrm>
-          <a:prstGeom prst="rect">
-            <a:avLst/>
-          </a:prstGeom>
-          <a:solidFill>
-            <a:srgbClr val="0078D4"/>
-          </a:solidFill>
-          <a:ln>
-            <a:noFill/>
-          </a:ln>
-        </p:spPr>
-        <p:style>
-          <a:lnRef idx="1">
-            <a:schemeClr val="accent1"/>
-          </a:lnRef>
-          <a:fillRef idx="3">
-            <a:schemeClr val="accent1"/>
-          </a:fillRef>
-          <a:effectRef idx="2">
-            <a:schemeClr val="accent1"/>
-          </a:effectRef>
-          <a:fontRef idx="minor">
-            <a:schemeClr val="lt1"/>
-          </a:fontRef>
-        </p:style>
-        <p:txBody>
-          <a:bodyPr rtlCol="0" anchor="ctr"/>
-          <a:lstStyle/>
-          <a:p>
-            <a:pPr algn="ctr"/>
-          </a:p>
-        </p:txBody>
-      </p:sp>
-      <p:sp>
-        <p:nvSpPr>
-          <p:cNvPr id="5" name="TextBox 4"/>
-          <p:cNvSpPr txBox="1"/>
-          <p:nvPr/>
-        </p:nvSpPr>
-        <p:spPr>
-          <a:xfrm>
-            <a:off x="731520" y="1371600"/>
-            <a:ext cx="10515600" cy="4572000"/>
-          </a:xfrm>
-          <a:prstGeom prst="rect">
-            <a:avLst/>
-          </a:prstGeom>
-          <a:noFill/>
-        </p:spPr>
-        <p:txBody>
-          <a:bodyPr wrap="square">
-            <a:spAutoFit/>
-          </a:bodyPr>
-          <a:lstStyle/>
-          <a:p>
-            <a:pPr>
-              <a:spcBef>
-                <a:spcPts val="800"/>
-              </a:spcBef>
-              <a:spcAft>
-                <a:spcPts val="400"/>
-              </a:spcAft>
-            </a:pPr>
-            <a:r>
-              <a:rPr sz="1600" b="1">
-                <a:solidFill>
-                  <a:srgbClr val="0078D4"/>
-                </a:solidFill>
-                <a:latin typeface="Segoe UI"/>
-              </a:rPr>
-              <a:t>Immediate: Migrate gpt-5-chat Previews</a:t>
-            </a:r>
-            <a:r>
-              <a:rPr sz="1400" b="0">
-                <a:solidFill>
-                  <a:srgbClr val="FFFFFF"/>
-                </a:solidFill>
-                <a:latin typeface="Segoe UI"/>
-              </a:rPr>
-              <a:t>
-gpt-5-chat preview retires Mar 1, 2026. Switch to gpt-5.2-chat now.</a:t>
-            </a:r>
-          </a:p>
-          <a:p>
-            <a:pPr>
-              <a:spcBef>
-                <a:spcPts val="800"/>
-              </a:spcBef>
-              <a:spcAft>
-                <a:spcPts val="400"/>
-              </a:spcAft>
-            </a:pPr>
-            <a:r>
-              <a:rPr sz="1600" b="1">
-                <a:solidFill>
-                  <a:srgbClr val="0078D4"/>
-                </a:solidFill>
-                <a:latin typeface="Segoe UI"/>
-              </a:rPr>
-              <a:t>By Mar 9: Test gpt-4o &amp; gpt-4o-mini Workloads</a:t>
-            </a:r>
-            <a:r>
-              <a:rPr sz="1400" b="0">
-                <a:solidFill>
-                  <a:srgbClr val="FFFFFF"/>
-                </a:solidFill>
-                <a:latin typeface="Segoe UI"/>
-              </a:rPr>
-              <a:t>
-Auto-upgrades begin this date. Validate application behaviour on the latest GA models.</a:t>
-            </a:r>
-          </a:p>
-          <a:p>
-            <a:pPr>
-              <a:spcBef>
-                <a:spcPts val="800"/>
-              </a:spcBef>
-              <a:spcAft>
-                <a:spcPts val="400"/>
-              </a:spcAft>
-            </a:pPr>
-            <a:r>
-              <a:rPr sz="1600" b="1">
-                <a:solidFill>
-                  <a:srgbClr val="0078D4"/>
-                </a:solidFill>
-                <a:latin typeface="Segoe UI"/>
-              </a:rPr>
-              <a:t>By Mar 31: Complete Standard Migrations</a:t>
-            </a:r>
-            <a:r>
-              <a:rPr sz="1400" b="0">
-                <a:solidFill>
-                  <a:srgbClr val="FFFFFF"/>
-                </a:solidFill>
-                <a:latin typeface="Segoe UI"/>
-              </a:rPr>
-              <a:t>
-All Standard gpt-4o / gpt-4o-mini deployments must be migrated or tested.</a:t>
-            </a:r>
-          </a:p>
-          <a:p>
-            <a:pPr>
-              <a:spcBef>
-                <a:spcPts val="800"/>
-              </a:spcBef>
-              <a:spcAft>
-                <a:spcPts val="400"/>
-              </a:spcAft>
-            </a:pPr>
-            <a:r>
-              <a:rPr sz="1600" b="1">
-                <a:solidFill>
-                  <a:srgbClr val="0078D4"/>
-                </a:solidFill>
-                <a:latin typeface="Segoe UI"/>
-              </a:rPr>
-              <a:t>Migrate Fine-Tuned Models</a:t>
-            </a:r>
-            <a:r>
-              <a:rPr sz="1400" b="0">
-                <a:solidFill>
-                  <a:srgbClr val="FFFFFF"/>
-                </a:solidFill>
-                <a:latin typeface="Segoe UI"/>
-              </a:rPr>
-              <a:t>
-Fine-tuned deployments on retired bases are NOT auto-upgraded. Re-train on a supported base model before the retirement date.</a:t>
-            </a:r>
-          </a:p>
-          <a:p>
-            <a:pPr>
-              <a:spcBef>
-                <a:spcPts val="800"/>
-              </a:spcBef>
-              <a:spcAft>
-                <a:spcPts val="400"/>
-              </a:spcAft>
-            </a:pPr>
-            <a:r>
-              <a:rPr sz="1600" b="1">
-                <a:solidFill>
-                  <a:srgbClr val="0078D4"/>
-                </a:solidFill>
-                <a:latin typeface="Segoe UI"/>
-              </a:rPr>
-              <a:t>Monitor the Retirements Page</a:t>
-            </a:r>
-            <a:r>
-              <a:rPr sz="1400" b="0">
-                <a:solidFill>
-                  <a:srgbClr val="FFFFFF"/>
-                </a:solidFill>
-                <a:latin typeface="Segoe UI"/>
-              </a:rPr>
-              <a:t>
-Bookmark learn.microsoft.com/azure/ai-foundry/openai/concepts/model-retirements.</a:t>
-            </a:r>
-          </a:p>
-        </p:txBody>
-      </p:sp>
-    </p:spTree>
-  </p:cSld>
-  <p:clrMapOvr>
-    <a:masterClrMapping/>
-  </p:clrMapOvr>
-</p:sld>
-</file>
-
 <file path=ppt/slides/slide9.xml><?xml version="1.0" encoding="utf-8"?>
 <p:sld xmlns:a="http://schemas.openxmlformats.org/drawingml/2006/main" xmlns:p="http://schemas.openxmlformats.org/presentationml/2006/main" xmlns:r="http://schemas.openxmlformats.org/officeDocument/2006/relationships">
   <p:cSld>
@@ -7084,7 +8504,7 @@
               </a:defRPr>
             </a:pPr>
             <a:r>
-              <a:t>Key February 2026 Updates – Quick Reference</a:t>
+              <a:t>Retirement Action Items</a:t>
             </a:r>
           </a:p>
         </p:txBody>
@@ -7132,786 +8552,174 @@
           </a:p>
         </p:txBody>
       </p:sp>
-      <p:graphicFrame>
-        <p:nvGraphicFramePr>
-          <p:cNvPr id="5" name="Table 4"/>
-          <p:cNvGraphicFramePr>
-            <a:graphicFrameLocks noGrp="1"/>
-          </p:cNvGraphicFramePr>
+      <p:sp>
+        <p:nvSpPr>
+          <p:cNvPr id="5" name="TextBox 4"/>
+          <p:cNvSpPr txBox="1"/>
           <p:nvPr/>
-        </p:nvGraphicFramePr>
-        <p:xfrm>
-          <a:off x="457200" y="1371600"/>
-          <a:ext cx="11247120" cy="4389120"/>
-        </p:xfrm>
-        <a:graphic>
-          <a:graphicData uri="http://schemas.openxmlformats.org/drawingml/2006/table">
-            <a:tbl>
-              <a:tblPr firstRow="1" bandRow="1">
-                <a:tableStyleId>{5C22544A-7EE6-4342-B048-85BDC9FD1C3A}</a:tableStyleId>
-              </a:tblPr>
-              <a:tblGrid>
-                <a:gridCol w="3200400"/>
-                <a:gridCol w="1828800"/>
-                <a:gridCol w="4572000"/>
-                <a:gridCol w="1645920"/>
-              </a:tblGrid>
-              <a:tr h="548640">
-                <a:tc>
-                  <a:txBody>
-                    <a:bodyPr/>
-                    <a:lstStyle/>
-                    <a:p>
-                      <a:pPr algn="l"/>
-                      <a:r>
-                        <a:rPr sz="1400" b="1">
-                          <a:solidFill>
-                            <a:srgbClr val="FFFFFF"/>
-                          </a:solidFill>
-                          <a:latin typeface="Segoe UI"/>
-                        </a:rPr>
-                        <a:t>Item</a:t>
-                      </a:r>
-                    </a:p>
-                  </a:txBody>
-                  <a:tcPr anchor="ctr">
-                    <a:solidFill>
-                      <a:srgbClr val="0078D4"/>
-                    </a:solidFill>
-                  </a:tcPr>
-                </a:tc>
-                <a:tc>
-                  <a:txBody>
-                    <a:bodyPr/>
-                    <a:lstStyle/>
-                    <a:p>
-                      <a:pPr algn="l"/>
-                      <a:r>
-                        <a:rPr sz="1400" b="1">
-                          <a:solidFill>
-                            <a:srgbClr val="FFFFFF"/>
-                          </a:solidFill>
-                          <a:latin typeface="Segoe UI"/>
-                        </a:rPr>
-                        <a:t>Category</a:t>
-                      </a:r>
-                    </a:p>
-                  </a:txBody>
-                  <a:tcPr anchor="ctr">
-                    <a:solidFill>
-                      <a:srgbClr val="0078D4"/>
-                    </a:solidFill>
-                  </a:tcPr>
-                </a:tc>
-                <a:tc>
-                  <a:txBody>
-                    <a:bodyPr/>
-                    <a:lstStyle/>
-                    <a:p>
-                      <a:pPr algn="l"/>
-                      <a:r>
-                        <a:rPr sz="1400" b="1">
-                          <a:solidFill>
-                            <a:srgbClr val="FFFFFF"/>
-                          </a:solidFill>
-                          <a:latin typeface="Segoe UI"/>
-                        </a:rPr>
-                        <a:t>Highlight</a:t>
-                      </a:r>
-                    </a:p>
-                  </a:txBody>
-                  <a:tcPr anchor="ctr">
-                    <a:solidFill>
-                      <a:srgbClr val="0078D4"/>
-                    </a:solidFill>
-                  </a:tcPr>
-                </a:tc>
-                <a:tc>
-                  <a:txBody>
-                    <a:bodyPr/>
-                    <a:lstStyle/>
-                    <a:p>
-                      <a:pPr algn="l"/>
-                      <a:r>
-                        <a:rPr sz="1400" b="1">
-                          <a:solidFill>
-                            <a:srgbClr val="FFFFFF"/>
-                          </a:solidFill>
-                          <a:latin typeface="Segoe UI"/>
-                        </a:rPr>
-                        <a:t>Date</a:t>
-                      </a:r>
-                    </a:p>
-                  </a:txBody>
-                  <a:tcPr anchor="ctr">
-                    <a:solidFill>
-                      <a:srgbClr val="0078D4"/>
-                    </a:solidFill>
-                  </a:tcPr>
-                </a:tc>
-              </a:tr>
-              <a:tr h="548640">
-                <a:tc>
-                  <a:txBody>
-                    <a:bodyPr/>
-                    <a:lstStyle/>
-                    <a:p>
-                      <a:pPr algn="l"/>
-                      <a:r>
-                        <a:rPr sz="1300" b="0">
-                          <a:solidFill>
-                            <a:srgbClr val="FFFFFF"/>
-                          </a:solidFill>
-                          <a:latin typeface="Segoe UI"/>
-                        </a:rPr>
-                        <a:t>Claude Sonnet 4.6</a:t>
-                      </a:r>
-                    </a:p>
-                  </a:txBody>
-                  <a:tcPr anchor="ctr">
-                    <a:solidFill>
-                      <a:srgbClr val="2A2A2A"/>
-                    </a:solidFill>
-                  </a:tcPr>
-                </a:tc>
-                <a:tc>
-                  <a:txBody>
-                    <a:bodyPr/>
-                    <a:lstStyle/>
-                    <a:p>
-                      <a:pPr algn="l"/>
-                      <a:r>
-                        <a:rPr sz="1300" b="0">
-                          <a:solidFill>
-                            <a:srgbClr val="FFFFFF"/>
-                          </a:solidFill>
-                          <a:latin typeface="Segoe UI"/>
-                        </a:rPr>
-                        <a:t>Model Release</a:t>
-                      </a:r>
-                    </a:p>
-                  </a:txBody>
-                  <a:tcPr anchor="ctr">
-                    <a:solidFill>
-                      <a:srgbClr val="2A2A2A"/>
-                    </a:solidFill>
-                  </a:tcPr>
-                </a:tc>
-                <a:tc>
-                  <a:txBody>
-                    <a:bodyPr/>
-                    <a:lstStyle/>
-                    <a:p>
-                      <a:pPr algn="l"/>
-                      <a:r>
-                        <a:rPr sz="1300" b="0">
-                          <a:solidFill>
-                            <a:srgbClr val="FFFFFF"/>
-                          </a:solidFill>
-                          <a:latin typeface="Segoe UI"/>
-                        </a:rPr>
-                        <a:t>Frontier performance for coding &amp; agents at scale</a:t>
-                      </a:r>
-                    </a:p>
-                  </a:txBody>
-                  <a:tcPr anchor="ctr">
-                    <a:solidFill>
-                      <a:srgbClr val="2A2A2A"/>
-                    </a:solidFill>
-                  </a:tcPr>
-                </a:tc>
-                <a:tc>
-                  <a:txBody>
-                    <a:bodyPr/>
-                    <a:lstStyle/>
-                    <a:p>
-                      <a:pPr algn="l"/>
-                      <a:r>
-                        <a:rPr sz="1300" b="0">
-                          <a:solidFill>
-                            <a:srgbClr val="FFFFFF"/>
-                          </a:solidFill>
-                          <a:latin typeface="Segoe UI"/>
-                        </a:rPr>
-                        <a:t>Feb 17</a:t>
-                      </a:r>
-                    </a:p>
-                  </a:txBody>
-                  <a:tcPr anchor="ctr">
-                    <a:solidFill>
-                      <a:srgbClr val="2A2A2A"/>
-                    </a:solidFill>
-                  </a:tcPr>
-                </a:tc>
-              </a:tr>
-              <a:tr h="548640">
-                <a:tc>
-                  <a:txBody>
-                    <a:bodyPr/>
-                    <a:lstStyle/>
-                    <a:p>
-                      <a:pPr algn="l"/>
-                      <a:r>
-                        <a:rPr sz="1300" b="0">
-                          <a:solidFill>
-                            <a:srgbClr val="FFFFFF"/>
-                          </a:solidFill>
-                          <a:latin typeface="Segoe UI"/>
-                        </a:rPr>
-                        <a:t>Claude Opus 4.6</a:t>
-                      </a:r>
-                    </a:p>
-                  </a:txBody>
-                  <a:tcPr anchor="ctr">
-                    <a:solidFill>
-                      <a:srgbClr val="222222"/>
-                    </a:solidFill>
-                  </a:tcPr>
-                </a:tc>
-                <a:tc>
-                  <a:txBody>
-                    <a:bodyPr/>
-                    <a:lstStyle/>
-                    <a:p>
-                      <a:pPr algn="l"/>
-                      <a:r>
-                        <a:rPr sz="1300" b="0">
-                          <a:solidFill>
-                            <a:srgbClr val="FFFFFF"/>
-                          </a:solidFill>
-                          <a:latin typeface="Segoe UI"/>
-                        </a:rPr>
-                        <a:t>Model Release</a:t>
-                      </a:r>
-                    </a:p>
-                  </a:txBody>
-                  <a:tcPr anchor="ctr">
-                    <a:solidFill>
-                      <a:srgbClr val="222222"/>
-                    </a:solidFill>
-                  </a:tcPr>
-                </a:tc>
-                <a:tc>
-                  <a:txBody>
-                    <a:bodyPr/>
-                    <a:lstStyle/>
-                    <a:p>
-                      <a:pPr algn="l"/>
-                      <a:r>
-                        <a:rPr sz="1300" b="0">
-                          <a:solidFill>
-                            <a:srgbClr val="FFFFFF"/>
-                          </a:solidFill>
-                          <a:latin typeface="Segoe UI"/>
-                        </a:rPr>
-                        <a:t>End-to-end autonomous task execution</a:t>
-                      </a:r>
-                    </a:p>
-                  </a:txBody>
-                  <a:tcPr anchor="ctr">
-                    <a:solidFill>
-                      <a:srgbClr val="222222"/>
-                    </a:solidFill>
-                  </a:tcPr>
-                </a:tc>
-                <a:tc>
-                  <a:txBody>
-                    <a:bodyPr/>
-                    <a:lstStyle/>
-                    <a:p>
-                      <a:pPr algn="l"/>
-                      <a:r>
-                        <a:rPr sz="1300" b="0">
-                          <a:solidFill>
-                            <a:srgbClr val="FFFFFF"/>
-                          </a:solidFill>
-                          <a:latin typeface="Segoe UI"/>
-                        </a:rPr>
-                        <a:t>Feb 5</a:t>
-                      </a:r>
-                    </a:p>
-                  </a:txBody>
-                  <a:tcPr anchor="ctr">
-                    <a:solidFill>
-                      <a:srgbClr val="222222"/>
-                    </a:solidFill>
-                  </a:tcPr>
-                </a:tc>
-              </a:tr>
-              <a:tr h="548640">
-                <a:tc>
-                  <a:txBody>
-                    <a:bodyPr/>
-                    <a:lstStyle/>
-                    <a:p>
-                      <a:pPr algn="l"/>
-                      <a:r>
-                        <a:rPr sz="1300" b="0">
-                          <a:solidFill>
-                            <a:srgbClr val="FFFFFF"/>
-                          </a:solidFill>
-                          <a:latin typeface="Segoe UI"/>
-                        </a:rPr>
-                        <a:t>PostgreSQL for AI</a:t>
-                      </a:r>
-                    </a:p>
-                  </a:txBody>
-                  <a:tcPr anchor="ctr">
-                    <a:solidFill>
-                      <a:srgbClr val="2A2A2A"/>
-                    </a:solidFill>
-                  </a:tcPr>
-                </a:tc>
-                <a:tc>
-                  <a:txBody>
-                    <a:bodyPr/>
-                    <a:lstStyle/>
-                    <a:p>
-                      <a:pPr algn="l"/>
-                      <a:r>
-                        <a:rPr sz="1300" b="0">
-                          <a:solidFill>
-                            <a:srgbClr val="FFFFFF"/>
-                          </a:solidFill>
-                          <a:latin typeface="Segoe UI"/>
-                        </a:rPr>
-                        <a:t>Data Service</a:t>
-                      </a:r>
-                    </a:p>
-                  </a:txBody>
-                  <a:tcPr anchor="ctr">
-                    <a:solidFill>
-                      <a:srgbClr val="2A2A2A"/>
-                    </a:solidFill>
-                  </a:tcPr>
-                </a:tc>
-                <a:tc>
-                  <a:txBody>
-                    <a:bodyPr/>
-                    <a:lstStyle/>
-                    <a:p>
-                      <a:pPr algn="l"/>
-                      <a:r>
-                        <a:rPr sz="1300" b="0">
-                          <a:solidFill>
-                            <a:srgbClr val="FFFFFF"/>
-                          </a:solidFill>
-                          <a:latin typeface="Segoe UI"/>
-                        </a:rPr>
-                        <a:t>DiskANN, MCP server, Copilot SQL, HorizonDB preview</a:t>
-                      </a:r>
-                    </a:p>
-                  </a:txBody>
-                  <a:tcPr anchor="ctr">
-                    <a:solidFill>
-                      <a:srgbClr val="2A2A2A"/>
-                    </a:solidFill>
-                  </a:tcPr>
-                </a:tc>
-                <a:tc>
-                  <a:txBody>
-                    <a:bodyPr/>
-                    <a:lstStyle/>
-                    <a:p>
-                      <a:pPr algn="l"/>
-                      <a:r>
-                        <a:rPr sz="1300" b="0">
-                          <a:solidFill>
-                            <a:srgbClr val="FFFFFF"/>
-                          </a:solidFill>
-                          <a:latin typeface="Segoe UI"/>
-                        </a:rPr>
-                        <a:t>Feb 2</a:t>
-                      </a:r>
-                    </a:p>
-                  </a:txBody>
-                  <a:tcPr anchor="ctr">
-                    <a:solidFill>
-                      <a:srgbClr val="2A2A2A"/>
-                    </a:solidFill>
-                  </a:tcPr>
-                </a:tc>
-              </a:tr>
-              <a:tr h="548640">
-                <a:tc>
-                  <a:txBody>
-                    <a:bodyPr/>
-                    <a:lstStyle/>
-                    <a:p>
-                      <a:pPr algn="l"/>
-                      <a:r>
-                        <a:rPr sz="1300" b="0">
-                          <a:solidFill>
-                            <a:srgbClr val="FFFFFF"/>
-                          </a:solidFill>
-                          <a:latin typeface="Segoe UI"/>
-                        </a:rPr>
-                        <a:t>High-Temp Superconductors</a:t>
-                      </a:r>
-                    </a:p>
-                  </a:txBody>
-                  <a:tcPr anchor="ctr">
-                    <a:solidFill>
-                      <a:srgbClr val="222222"/>
-                    </a:solidFill>
-                  </a:tcPr>
-                </a:tc>
-                <a:tc>
-                  <a:txBody>
-                    <a:bodyPr/>
-                    <a:lstStyle/>
-                    <a:p>
-                      <a:pPr algn="l"/>
-                      <a:r>
-                        <a:rPr sz="1300" b="0">
-                          <a:solidFill>
-                            <a:srgbClr val="FFFFFF"/>
-                          </a:solidFill>
-                          <a:latin typeface="Segoe UI"/>
-                        </a:rPr>
-                        <a:t>Infrastructure</a:t>
-                      </a:r>
-                    </a:p>
-                  </a:txBody>
-                  <a:tcPr anchor="ctr">
-                    <a:solidFill>
-                      <a:srgbClr val="222222"/>
-                    </a:solidFill>
-                  </a:tcPr>
-                </a:tc>
-                <a:tc>
-                  <a:txBody>
-                    <a:bodyPr/>
-                    <a:lstStyle/>
-                    <a:p>
-                      <a:pPr algn="l"/>
-                      <a:r>
-                        <a:rPr sz="1300" b="0">
-                          <a:solidFill>
-                            <a:srgbClr val="FFFFFF"/>
-                          </a:solidFill>
-                          <a:latin typeface="Segoe UI"/>
-                        </a:rPr>
-                        <a:t>Exploring superconductors for datacenter power</a:t>
-                      </a:r>
-                    </a:p>
-                  </a:txBody>
-                  <a:tcPr anchor="ctr">
-                    <a:solidFill>
-                      <a:srgbClr val="222222"/>
-                    </a:solidFill>
-                  </a:tcPr>
-                </a:tc>
-                <a:tc>
-                  <a:txBody>
-                    <a:bodyPr/>
-                    <a:lstStyle/>
-                    <a:p>
-                      <a:pPr algn="l"/>
-                      <a:r>
-                        <a:rPr sz="1300" b="0">
-                          <a:solidFill>
-                            <a:srgbClr val="FFFFFF"/>
-                          </a:solidFill>
-                          <a:latin typeface="Segoe UI"/>
-                        </a:rPr>
-                        <a:t>Feb 10</a:t>
-                      </a:r>
-                    </a:p>
-                  </a:txBody>
-                  <a:tcPr anchor="ctr">
-                    <a:solidFill>
-                      <a:srgbClr val="222222"/>
-                    </a:solidFill>
-                  </a:tcPr>
-                </a:tc>
-              </a:tr>
-              <a:tr h="548640">
-                <a:tc>
-                  <a:txBody>
-                    <a:bodyPr/>
-                    <a:lstStyle/>
-                    <a:p>
-                      <a:pPr algn="l"/>
-                      <a:r>
-                        <a:rPr sz="1300" b="0">
-                          <a:solidFill>
-                            <a:srgbClr val="FFFFFF"/>
-                          </a:solidFill>
-                          <a:latin typeface="Segoe UI"/>
-                        </a:rPr>
-                        <a:t>Agentic Cloud Ops</a:t>
-                      </a:r>
-                    </a:p>
-                  </a:txBody>
-                  <a:tcPr anchor="ctr">
-                    <a:solidFill>
-                      <a:srgbClr val="2A2A2A"/>
-                    </a:solidFill>
-                  </a:tcPr>
-                </a:tc>
-                <a:tc>
-                  <a:txBody>
-                    <a:bodyPr/>
-                    <a:lstStyle/>
-                    <a:p>
-                      <a:pPr algn="l"/>
-                      <a:r>
-                        <a:rPr sz="1300" b="0">
-                          <a:solidFill>
-                            <a:srgbClr val="FFFFFF"/>
-                          </a:solidFill>
-                          <a:latin typeface="Segoe UI"/>
-                        </a:rPr>
-                        <a:t>Framework</a:t>
-                      </a:r>
-                    </a:p>
-                  </a:txBody>
-                  <a:tcPr anchor="ctr">
-                    <a:solidFill>
-                      <a:srgbClr val="2A2A2A"/>
-                    </a:solidFill>
-                  </a:tcPr>
-                </a:tc>
-                <a:tc>
-                  <a:txBody>
-                    <a:bodyPr/>
-                    <a:lstStyle/>
-                    <a:p>
-                      <a:pPr algn="l"/>
-                      <a:r>
-                        <a:rPr sz="1300" b="0">
-                          <a:solidFill>
-                            <a:srgbClr val="FFFFFF"/>
-                          </a:solidFill>
-                          <a:latin typeface="Segoe UI"/>
-                        </a:rPr>
-                        <a:t>AI agents for cloud operations &amp; incident response</a:t>
-                      </a:r>
-                    </a:p>
-                  </a:txBody>
-                  <a:tcPr anchor="ctr">
-                    <a:solidFill>
-                      <a:srgbClr val="2A2A2A"/>
-                    </a:solidFill>
-                  </a:tcPr>
-                </a:tc>
-                <a:tc>
-                  <a:txBody>
-                    <a:bodyPr/>
-                    <a:lstStyle/>
-                    <a:p>
-                      <a:pPr algn="l"/>
-                      <a:r>
-                        <a:rPr sz="1300" b="0">
-                          <a:solidFill>
-                            <a:srgbClr val="FFFFFF"/>
-                          </a:solidFill>
-                          <a:latin typeface="Segoe UI"/>
-                        </a:rPr>
-                        <a:t>Feb 11</a:t>
-                      </a:r>
-                    </a:p>
-                  </a:txBody>
-                  <a:tcPr anchor="ctr">
-                    <a:solidFill>
-                      <a:srgbClr val="2A2A2A"/>
-                    </a:solidFill>
-                  </a:tcPr>
-                </a:tc>
-              </a:tr>
-              <a:tr h="548640">
-                <a:tc>
-                  <a:txBody>
-                    <a:bodyPr/>
-                    <a:lstStyle/>
-                    <a:p>
-                      <a:pPr algn="l"/>
-                      <a:r>
-                        <a:rPr sz="1300" b="0">
-                          <a:solidFill>
-                            <a:srgbClr val="FFFFFF"/>
-                          </a:solidFill>
-                          <a:latin typeface="Segoe UI"/>
-                        </a:rPr>
-                        <a:t>Pantone Case Study</a:t>
-                      </a:r>
-                    </a:p>
-                  </a:txBody>
-                  <a:tcPr anchor="ctr">
-                    <a:solidFill>
-                      <a:srgbClr val="222222"/>
-                    </a:solidFill>
-                  </a:tcPr>
-                </a:tc>
-                <a:tc>
-                  <a:txBody>
-                    <a:bodyPr/>
-                    <a:lstStyle/>
-                    <a:p>
-                      <a:pPr algn="l"/>
-                      <a:r>
-                        <a:rPr sz="1300" b="0">
-                          <a:solidFill>
-                            <a:srgbClr val="FFFFFF"/>
-                          </a:solidFill>
-                          <a:latin typeface="Segoe UI"/>
-                        </a:rPr>
-                        <a:t>Ecosystem</a:t>
-                      </a:r>
-                    </a:p>
-                  </a:txBody>
-                  <a:tcPr anchor="ctr">
-                    <a:solidFill>
-                      <a:srgbClr val="222222"/>
-                    </a:solidFill>
-                  </a:tcPr>
-                </a:tc>
-                <a:tc>
-                  <a:txBody>
-                    <a:bodyPr/>
-                    <a:lstStyle/>
-                    <a:p>
-                      <a:pPr algn="l"/>
-                      <a:r>
-                        <a:rPr sz="1300" b="0">
-                          <a:solidFill>
-                            <a:srgbClr val="FFFFFF"/>
-                          </a:solidFill>
-                          <a:latin typeface="Segoe UI"/>
-                        </a:rPr>
-                        <a:t>Agentic AI + AI-ready database in production</a:t>
-                      </a:r>
-                    </a:p>
-                  </a:txBody>
-                  <a:tcPr anchor="ctr">
-                    <a:solidFill>
-                      <a:srgbClr val="222222"/>
-                    </a:solidFill>
-                  </a:tcPr>
-                </a:tc>
-                <a:tc>
-                  <a:txBody>
-                    <a:bodyPr/>
-                    <a:lstStyle/>
-                    <a:p>
-                      <a:pPr algn="l"/>
-                      <a:r>
-                        <a:rPr sz="1300" b="0">
-                          <a:solidFill>
-                            <a:srgbClr val="FFFFFF"/>
-                          </a:solidFill>
-                          <a:latin typeface="Segoe UI"/>
-                        </a:rPr>
-                        <a:t>Feb 12</a:t>
-                      </a:r>
-                    </a:p>
-                  </a:txBody>
-                  <a:tcPr anchor="ctr">
-                    <a:solidFill>
-                      <a:srgbClr val="222222"/>
-                    </a:solidFill>
-                  </a:tcPr>
-                </a:tc>
-              </a:tr>
-              <a:tr h="548640">
-                <a:tc>
-                  <a:txBody>
-                    <a:bodyPr/>
-                    <a:lstStyle/>
-                    <a:p>
-                      <a:pPr algn="l"/>
-                      <a:r>
-                        <a:rPr sz="1300" b="0">
-                          <a:solidFill>
-                            <a:srgbClr val="FFFFFF"/>
-                          </a:solidFill>
-                          <a:latin typeface="Segoe UI"/>
-                        </a:rPr>
-                        <a:t>Agents League</a:t>
-                      </a:r>
-                    </a:p>
-                  </a:txBody>
-                  <a:tcPr anchor="ctr">
-                    <a:solidFill>
-                      <a:srgbClr val="2A2A2A"/>
-                    </a:solidFill>
-                  </a:tcPr>
-                </a:tc>
-                <a:tc>
-                  <a:txBody>
-                    <a:bodyPr/>
-                    <a:lstStyle/>
-                    <a:p>
-                      <a:pPr algn="l"/>
-                      <a:r>
-                        <a:rPr sz="1300" b="0">
-                          <a:solidFill>
-                            <a:srgbClr val="FFFFFF"/>
-                          </a:solidFill>
-                          <a:latin typeface="Segoe UI"/>
-                        </a:rPr>
-                        <a:t>Community</a:t>
-                      </a:r>
-                    </a:p>
-                  </a:txBody>
-                  <a:tcPr anchor="ctr">
-                    <a:solidFill>
-                      <a:srgbClr val="2A2A2A"/>
-                    </a:solidFill>
-                  </a:tcPr>
-                </a:tc>
-                <a:tc>
-                  <a:txBody>
-                    <a:bodyPr/>
-                    <a:lstStyle/>
-                    <a:p>
-                      <a:pPr algn="l"/>
-                      <a:r>
-                        <a:rPr sz="1300" b="0">
-                          <a:solidFill>
-                            <a:srgbClr val="FFFFFF"/>
-                          </a:solidFill>
-                          <a:latin typeface="Segoe UI"/>
-                        </a:rPr>
-                        <a:t>Developer challenge for building AI agents</a:t>
-                      </a:r>
-                    </a:p>
-                  </a:txBody>
-                  <a:tcPr anchor="ctr">
-                    <a:solidFill>
-                      <a:srgbClr val="2A2A2A"/>
-                    </a:solidFill>
-                  </a:tcPr>
-                </a:tc>
-                <a:tc>
-                  <a:txBody>
-                    <a:bodyPr/>
-                    <a:lstStyle/>
-                    <a:p>
-                      <a:pPr algn="l"/>
-                      <a:r>
-                        <a:rPr sz="1300" b="0">
-                          <a:solidFill>
-                            <a:srgbClr val="FFFFFF"/>
-                          </a:solidFill>
-                          <a:latin typeface="Segoe UI"/>
-                        </a:rPr>
-                        <a:t>Feb 16–27</a:t>
-                      </a:r>
-                    </a:p>
-                  </a:txBody>
-                  <a:tcPr anchor="ctr">
-                    <a:solidFill>
-                      <a:srgbClr val="2A2A2A"/>
-                    </a:solidFill>
-                  </a:tcPr>
-                </a:tc>
-              </a:tr>
-            </a:tbl>
-          </a:graphicData>
-        </a:graphic>
-      </p:graphicFrame>
+        </p:nvSpPr>
+        <p:spPr>
+          <a:xfrm>
+            <a:off x="731520" y="1371600"/>
+            <a:ext cx="10515600" cy="4572000"/>
+          </a:xfrm>
+          <a:prstGeom prst="rect">
+            <a:avLst/>
+          </a:prstGeom>
+          <a:noFill/>
+        </p:spPr>
+        <p:txBody>
+          <a:bodyPr wrap="square">
+            <a:spAutoFit/>
+          </a:bodyPr>
+          <a:lstStyle/>
+          <a:p>
+            <a:pPr>
+              <a:spcBef>
+                <a:spcPts val="800"/>
+              </a:spcBef>
+              <a:spcAft>
+                <a:spcPts val="400"/>
+              </a:spcAft>
+            </a:pPr>
+            <a:r>
+              <a:rPr sz="1600" b="1">
+                <a:solidFill>
+                  <a:srgbClr val="0078D4"/>
+                </a:solidFill>
+                <a:latin typeface="Segoe UI"/>
+              </a:rPr>
+              <a:t>Immediate: Migrate gpt-5-chat Previews</a:t>
+            </a:r>
+            <a:r>
+              <a:rPr sz="1400" b="0">
+                <a:solidFill>
+                  <a:srgbClr val="FFFFFF"/>
+                </a:solidFill>
+                <a:latin typeface="Segoe UI"/>
+              </a:rPr>
+              <a:t>
+gpt-5-chat preview retires Mar 1, 2026. Switch to gpt-5.2-chat now.</a:t>
+            </a:r>
+          </a:p>
+          <a:p>
+            <a:pPr>
+              <a:spcBef>
+                <a:spcPts val="800"/>
+              </a:spcBef>
+              <a:spcAft>
+                <a:spcPts val="400"/>
+              </a:spcAft>
+            </a:pPr>
+            <a:r>
+              <a:rPr sz="1600" b="1">
+                <a:solidFill>
+                  <a:srgbClr val="0078D4"/>
+                </a:solidFill>
+                <a:latin typeface="Segoe UI"/>
+              </a:rPr>
+              <a:t>By Mar 9: Test gpt-4o &amp; gpt-4o-mini Workloads</a:t>
+            </a:r>
+            <a:r>
+              <a:rPr sz="1400" b="0">
+                <a:solidFill>
+                  <a:srgbClr val="FFFFFF"/>
+                </a:solidFill>
+                <a:latin typeface="Segoe UI"/>
+              </a:rPr>
+              <a:t>
+Auto-upgrades begin this date. Validate application behaviour on the latest GA models.</a:t>
+            </a:r>
+          </a:p>
+          <a:p>
+            <a:pPr>
+              <a:spcBef>
+                <a:spcPts val="800"/>
+              </a:spcBef>
+              <a:spcAft>
+                <a:spcPts val="400"/>
+              </a:spcAft>
+            </a:pPr>
+            <a:r>
+              <a:rPr sz="1600" b="1">
+                <a:solidFill>
+                  <a:srgbClr val="0078D4"/>
+                </a:solidFill>
+                <a:latin typeface="Segoe UI"/>
+              </a:rPr>
+              <a:t>By Mar 31: Complete Standard Migrations</a:t>
+            </a:r>
+            <a:r>
+              <a:rPr sz="1400" b="0">
+                <a:solidFill>
+                  <a:srgbClr val="FFFFFF"/>
+                </a:solidFill>
+                <a:latin typeface="Segoe UI"/>
+              </a:rPr>
+              <a:t>
+All Standard gpt-4o / gpt-4o-mini deployments must be migrated or tested.</a:t>
+            </a:r>
+          </a:p>
+          <a:p>
+            <a:pPr>
+              <a:spcBef>
+                <a:spcPts val="800"/>
+              </a:spcBef>
+              <a:spcAft>
+                <a:spcPts val="400"/>
+              </a:spcAft>
+            </a:pPr>
+            <a:r>
+              <a:rPr sz="1600" b="1">
+                <a:solidFill>
+                  <a:srgbClr val="0078D4"/>
+                </a:solidFill>
+                <a:latin typeface="Segoe UI"/>
+              </a:rPr>
+              <a:t>Migrate Fine-Tuned Models</a:t>
+            </a:r>
+            <a:r>
+              <a:rPr sz="1400" b="0">
+                <a:solidFill>
+                  <a:srgbClr val="FFFFFF"/>
+                </a:solidFill>
+                <a:latin typeface="Segoe UI"/>
+              </a:rPr>
+              <a:t>
+Fine-tuned deployments on retired bases are NOT auto-upgraded. Re-train on a supported base model before the retirement date.</a:t>
+            </a:r>
+          </a:p>
+          <a:p>
+            <a:pPr>
+              <a:spcBef>
+                <a:spcPts val="800"/>
+              </a:spcBef>
+              <a:spcAft>
+                <a:spcPts val="400"/>
+              </a:spcAft>
+            </a:pPr>
+            <a:r>
+              <a:rPr sz="1600" b="1">
+                <a:solidFill>
+                  <a:srgbClr val="0078D4"/>
+                </a:solidFill>
+                <a:latin typeface="Segoe UI"/>
+              </a:rPr>
+              <a:t>Monitor the Retirements Page</a:t>
+            </a:r>
+            <a:r>
+              <a:rPr sz="1400" b="0">
+                <a:solidFill>
+                  <a:srgbClr val="FFFFFF"/>
+                </a:solidFill>
+                <a:latin typeface="Segoe UI"/>
+              </a:rPr>
+              <a:t>
+Bookmark learn.microsoft.com/azure/ai-foundry/openai/concepts/model-retirements.</a:t>
+            </a:r>
+          </a:p>
+        </p:txBody>
+      </p:sp>
     </p:spTree>
   </p:cSld>
   <p:clrMapOvr>

</xml_diff>